<commit_message>
Clean for personal repo
</commit_message>
<xml_diff>
--- a/ShelbyFirst.pptx
+++ b/ShelbyFirst.pptx
@@ -1174,6 +1174,13 @@
           </a:solidFill>
           <a:ln/>
         </p:spPr>
+        <p:txBody>
+          <a:bodyPr/>
+          <a:lstStyle/>
+          <a:p>
+            <a:endParaRPr lang="en-US"/>
+          </a:p>
+        </p:txBody>
       </p:sp>
       <p:sp>
         <p:nvSpPr>
@@ -1194,6 +1201,13 @@
           </a:solidFill>
           <a:ln/>
         </p:spPr>
+        <p:txBody>
+          <a:bodyPr/>
+          <a:lstStyle/>
+          <a:p>
+            <a:endParaRPr lang="en-US"/>
+          </a:p>
+        </p:txBody>
       </p:sp>
       <p:pic>
         <p:nvPicPr>
@@ -1273,6 +1287,13 @@
           </a:solidFill>
           <a:ln/>
         </p:spPr>
+        <p:txBody>
+          <a:bodyPr/>
+          <a:lstStyle/>
+          <a:p>
+            <a:endParaRPr lang="en-US"/>
+          </a:p>
+        </p:txBody>
       </p:sp>
       <p:sp>
         <p:nvSpPr>
@@ -1293,6 +1314,13 @@
           </a:solidFill>
           <a:ln/>
         </p:spPr>
+        <p:txBody>
+          <a:bodyPr/>
+          <a:lstStyle/>
+          <a:p>
+            <a:endParaRPr lang="en-US"/>
+          </a:p>
+        </p:txBody>
       </p:sp>
       <p:pic>
         <p:nvPicPr>
@@ -1697,6 +1725,13 @@
           </a:solidFill>
           <a:ln/>
         </p:spPr>
+        <p:txBody>
+          <a:bodyPr/>
+          <a:lstStyle/>
+          <a:p>
+            <a:endParaRPr lang="en-US"/>
+          </a:p>
+        </p:txBody>
       </p:sp>
       <p:sp>
         <p:nvSpPr>
@@ -1717,6 +1752,13 @@
           </a:solidFill>
           <a:ln/>
         </p:spPr>
+        <p:txBody>
+          <a:bodyPr/>
+          <a:lstStyle/>
+          <a:p>
+            <a:endParaRPr lang="en-US"/>
+          </a:p>
+        </p:txBody>
       </p:sp>
       <p:pic>
         <p:nvPicPr>
@@ -1796,6 +1838,13 @@
           </a:solidFill>
           <a:ln/>
         </p:spPr>
+        <p:txBody>
+          <a:bodyPr/>
+          <a:lstStyle/>
+          <a:p>
+            <a:endParaRPr lang="en-US"/>
+          </a:p>
+        </p:txBody>
       </p:sp>
       <p:sp>
         <p:nvSpPr>
@@ -1816,6 +1865,13 @@
           </a:solidFill>
           <a:ln/>
         </p:spPr>
+        <p:txBody>
+          <a:bodyPr/>
+          <a:lstStyle/>
+          <a:p>
+            <a:endParaRPr lang="en-US"/>
+          </a:p>
+        </p:txBody>
       </p:sp>
       <p:pic>
         <p:nvPicPr>
@@ -1895,6 +1951,13 @@
           </a:solidFill>
           <a:ln/>
         </p:spPr>
+        <p:txBody>
+          <a:bodyPr/>
+          <a:lstStyle/>
+          <a:p>
+            <a:endParaRPr lang="en-US"/>
+          </a:p>
+        </p:txBody>
       </p:sp>
       <p:sp>
         <p:nvSpPr>
@@ -1915,6 +1978,13 @@
           </a:solidFill>
           <a:ln/>
         </p:spPr>
+        <p:txBody>
+          <a:bodyPr/>
+          <a:lstStyle/>
+          <a:p>
+            <a:endParaRPr lang="en-US"/>
+          </a:p>
+        </p:txBody>
       </p:sp>
       <p:pic>
         <p:nvPicPr>
@@ -1994,6 +2064,13 @@
           </a:solidFill>
           <a:ln/>
         </p:spPr>
+        <p:txBody>
+          <a:bodyPr/>
+          <a:lstStyle/>
+          <a:p>
+            <a:endParaRPr lang="en-US"/>
+          </a:p>
+        </p:txBody>
       </p:sp>
       <p:sp>
         <p:nvSpPr>
@@ -2014,6 +2091,13 @@
           </a:solidFill>
           <a:ln/>
         </p:spPr>
+        <p:txBody>
+          <a:bodyPr/>
+          <a:lstStyle/>
+          <a:p>
+            <a:endParaRPr lang="en-US"/>
+          </a:p>
+        </p:txBody>
       </p:sp>
       <p:pic>
         <p:nvPicPr>
@@ -2093,6 +2177,13 @@
           </a:solidFill>
           <a:ln/>
         </p:spPr>
+        <p:txBody>
+          <a:bodyPr/>
+          <a:lstStyle/>
+          <a:p>
+            <a:endParaRPr lang="en-US"/>
+          </a:p>
+        </p:txBody>
       </p:sp>
       <p:sp>
         <p:nvSpPr>
@@ -2113,6 +2204,13 @@
           </a:solidFill>
           <a:ln/>
         </p:spPr>
+        <p:txBody>
+          <a:bodyPr/>
+          <a:lstStyle/>
+          <a:p>
+            <a:endParaRPr lang="en-US"/>
+          </a:p>
+        </p:txBody>
       </p:sp>
       <p:pic>
         <p:nvPicPr>
@@ -2192,6 +2290,13 @@
           </a:solidFill>
           <a:ln/>
         </p:spPr>
+        <p:txBody>
+          <a:bodyPr/>
+          <a:lstStyle/>
+          <a:p>
+            <a:endParaRPr lang="en-US"/>
+          </a:p>
+        </p:txBody>
       </p:sp>
       <p:sp>
         <p:nvSpPr>
@@ -2212,6 +2317,13 @@
           </a:solidFill>
           <a:ln/>
         </p:spPr>
+        <p:txBody>
+          <a:bodyPr/>
+          <a:lstStyle/>
+          <a:p>
+            <a:endParaRPr lang="en-US"/>
+          </a:p>
+        </p:txBody>
       </p:sp>
       <p:pic>
         <p:nvPicPr>
@@ -4677,843 +4789,1914 @@
           </a:p>
         </p:txBody>
       </p:sp>
-      <p:sp>
-        <p:nvSpPr>
-          <p:cNvPr id="4" name="Shape 2"/>
-          <p:cNvSpPr/>
-          <p:nvPr/>
-        </p:nvSpPr>
-        <p:spPr>
-          <a:xfrm>
-            <a:off x="731758" y="1625679"/>
-            <a:ext cx="1707356" cy="224195"/>
-          </a:xfrm>
-          <a:prstGeom prst="roundRect">
-            <a:avLst>
-              <a:gd name="adj" fmla="val 79940"/>
-            </a:avLst>
-          </a:prstGeom>
-          <a:solidFill>
-            <a:srgbClr val="FFFFFF">
-              <a:alpha val="20000"/>
-            </a:srgbClr>
-          </a:solidFill>
-          <a:ln w="7620">
+      <p:grpSp>
+        <p:nvGrpSpPr>
+          <p:cNvPr id="66" name="Group 65">
+            <a:extLst>
+              <a:ext uri="{FF2B5EF4-FFF2-40B4-BE49-F238E27FC236}">
+                <a16:creationId xmlns:a16="http://schemas.microsoft.com/office/drawing/2014/main" id="{ED4B4785-AE1B-AB95-A0B2-CB9A1CDB5D08}"/>
+              </a:ext>
+            </a:extLst>
+          </p:cNvPr>
+          <p:cNvGrpSpPr/>
+          <p:nvPr/>
+        </p:nvGrpSpPr>
+        <p:grpSpPr>
+          <a:xfrm>
+            <a:off x="693742" y="1754525"/>
+            <a:ext cx="4823064" cy="231362"/>
+            <a:chOff x="731758" y="1625679"/>
+            <a:chExt cx="5692616" cy="224195"/>
+          </a:xfrm>
+        </p:grpSpPr>
+        <p:sp>
+          <p:nvSpPr>
+            <p:cNvPr id="4" name="Shape 2"/>
+            <p:cNvSpPr/>
+            <p:nvPr/>
+          </p:nvSpPr>
+          <p:spPr>
+            <a:xfrm>
+              <a:off x="731758" y="1625679"/>
+              <a:ext cx="1707356" cy="224195"/>
+            </a:xfrm>
+            <a:prstGeom prst="roundRect">
+              <a:avLst>
+                <a:gd name="adj" fmla="val 79940"/>
+              </a:avLst>
+            </a:prstGeom>
             <a:solidFill>
-              <a:srgbClr val="000000"/>
+              <a:srgbClr val="FFFFFF">
+                <a:alpha val="20000"/>
+              </a:srgbClr>
             </a:solidFill>
-            <a:prstDash val="solid"/>
-          </a:ln>
-        </p:spPr>
-        <p:txBody>
-          <a:bodyPr/>
-          <a:lstStyle/>
-          <a:p>
-            <a:endParaRPr lang="en-US"/>
+            <a:ln w="7620">
+              <a:solidFill>
+                <a:srgbClr val="000000"/>
+              </a:solidFill>
+              <a:prstDash val="solid"/>
+            </a:ln>
+          </p:spPr>
+          <p:txBody>
+            <a:bodyPr/>
+            <a:lstStyle/>
+            <a:p>
+              <a:endParaRPr lang="en-US"/>
+            </a:p>
+          </p:txBody>
+        </p:sp>
+        <p:pic>
+          <p:nvPicPr>
+            <p:cNvPr id="5" name="Image 0" descr="preencoded.png"/>
+            <p:cNvPicPr>
+              <a:picLocks noChangeAspect="1"/>
+            </p:cNvPicPr>
+            <p:nvPr/>
+          </p:nvPicPr>
+          <p:blipFill>
+            <a:blip r:embed="rId3"/>
+            <a:stretch>
+              <a:fillRect/>
+            </a:stretch>
+          </p:blipFill>
+          <p:spPr>
+            <a:xfrm>
+              <a:off x="803315" y="1673781"/>
+              <a:ext cx="127992" cy="127992"/>
+            </a:xfrm>
+            <a:prstGeom prst="rect">
+              <a:avLst/>
+            </a:prstGeom>
+          </p:spPr>
+        </p:pic>
+        <p:sp>
+          <p:nvSpPr>
+            <p:cNvPr id="6" name="Text 3"/>
+            <p:cNvSpPr/>
+            <p:nvPr/>
+          </p:nvSpPr>
+          <p:spPr>
+            <a:xfrm>
+              <a:off x="973931" y="1654612"/>
+              <a:ext cx="1393627" cy="166330"/>
+            </a:xfrm>
+            <a:prstGeom prst="rect">
+              <a:avLst/>
+            </a:prstGeom>
+            <a:noFill/>
+            <a:ln/>
+          </p:spPr>
+          <p:txBody>
+            <a:bodyPr wrap="none" lIns="0" tIns="0" rIns="0" bIns="0" rtlCol="0" anchor="t"/>
+            <a:lstStyle/>
+            <a:p>
+              <a:pPr marL="0" indent="0" algn="l">
+                <a:lnSpc>
+                  <a:spcPts val="1300"/>
+                </a:lnSpc>
+                <a:buNone/>
+              </a:pPr>
+              <a:r>
+                <a:rPr lang="en-US" sz="1000" dirty="0">
+                  <a:solidFill>
+                    <a:srgbClr val="4C4C4D"/>
+                  </a:solidFill>
+                  <a:latin typeface="-apple-system, BlinkMacSystemFont, Segoe UI, Roboto, Helvetica Neue, Arial, sans-serif Medium" pitchFamily="34" charset="0"/>
+                  <a:ea typeface="-apple-system, BlinkMacSystemFont, Segoe UI, Roboto, Helvetica Neue, Arial, sans-serif Medium" pitchFamily="34" charset="-122"/>
+                  <a:cs typeface="-apple-system, BlinkMacSystemFont, Segoe UI, Roboto, Helvetica Neue, Arial, sans-serif Medium" pitchFamily="34" charset="-120"/>
+                </a:rPr>
+                <a:t>Our Shelby Community</a:t>
+              </a:r>
+              <a:endParaRPr lang="en-US" sz="1000" dirty="0"/>
+            </a:p>
+          </p:txBody>
+        </p:sp>
+        <p:sp>
+          <p:nvSpPr>
+            <p:cNvPr id="7" name="Shape 4"/>
+            <p:cNvSpPr/>
+            <p:nvPr/>
+          </p:nvSpPr>
+          <p:spPr>
+            <a:xfrm>
+              <a:off x="2500074" y="1625679"/>
+              <a:ext cx="1617226" cy="224195"/>
+            </a:xfrm>
+            <a:prstGeom prst="roundRect">
+              <a:avLst>
+                <a:gd name="adj" fmla="val 79940"/>
+              </a:avLst>
+            </a:prstGeom>
+            <a:solidFill>
+              <a:srgbClr val="FFFFFF">
+                <a:alpha val="20000"/>
+              </a:srgbClr>
+            </a:solidFill>
+            <a:ln w="7620">
+              <a:solidFill>
+                <a:srgbClr val="000000"/>
+              </a:solidFill>
+              <a:prstDash val="solid"/>
+            </a:ln>
+          </p:spPr>
+          <p:txBody>
+            <a:bodyPr/>
+            <a:lstStyle/>
+            <a:p>
+              <a:endParaRPr lang="en-US"/>
+            </a:p>
+          </p:txBody>
+        </p:sp>
+        <p:pic>
+          <p:nvPicPr>
+            <p:cNvPr id="8" name="Image 1" descr="preencoded.png"/>
+            <p:cNvPicPr>
+              <a:picLocks noChangeAspect="1"/>
+            </p:cNvPicPr>
+            <p:nvPr/>
+          </p:nvPicPr>
+          <p:blipFill>
+            <a:blip r:embed="rId4"/>
+            <a:stretch>
+              <a:fillRect/>
+            </a:stretch>
+          </p:blipFill>
+          <p:spPr>
+            <a:xfrm>
+              <a:off x="2571631" y="1673781"/>
+              <a:ext cx="127992" cy="127992"/>
+            </a:xfrm>
+            <a:prstGeom prst="rect">
+              <a:avLst/>
+            </a:prstGeom>
+          </p:spPr>
+        </p:pic>
+        <p:sp>
+          <p:nvSpPr>
+            <p:cNvPr id="9" name="Text 5"/>
+            <p:cNvSpPr/>
+            <p:nvPr/>
+          </p:nvSpPr>
+          <p:spPr>
+            <a:xfrm>
+              <a:off x="2742247" y="1654612"/>
+              <a:ext cx="1303496" cy="166330"/>
+            </a:xfrm>
+            <a:prstGeom prst="rect">
+              <a:avLst/>
+            </a:prstGeom>
+            <a:noFill/>
+            <a:ln/>
+          </p:spPr>
+          <p:txBody>
+            <a:bodyPr wrap="none" lIns="0" tIns="0" rIns="0" bIns="0" rtlCol="0" anchor="t"/>
+            <a:lstStyle/>
+            <a:p>
+              <a:pPr marL="0" indent="0" algn="l">
+                <a:lnSpc>
+                  <a:spcPts val="1300"/>
+                </a:lnSpc>
+                <a:buNone/>
+              </a:pPr>
+              <a:r>
+                <a:rPr lang="en-US" sz="1000" dirty="0">
+                  <a:solidFill>
+                    <a:srgbClr val="4C4C4D"/>
+                  </a:solidFill>
+                  <a:latin typeface="-apple-system, BlinkMacSystemFont, Segoe UI, Roboto, Helvetica Neue, Arial, sans-serif Medium" pitchFamily="34" charset="0"/>
+                  <a:ea typeface="-apple-system, BlinkMacSystemFont, Segoe UI, Roboto, Helvetica Neue, Arial, sans-serif Medium" pitchFamily="34" charset="-122"/>
+                  <a:cs typeface="-apple-system, BlinkMacSystemFont, Segoe UI, Roboto, Helvetica Neue, Arial, sans-serif Medium" pitchFamily="34" charset="-120"/>
+                </a:rPr>
+                <a:t>Rest of Shelby County</a:t>
+              </a:r>
+              <a:endParaRPr lang="en-US" sz="1000" dirty="0"/>
+            </a:p>
+          </p:txBody>
+        </p:sp>
+        <p:sp>
+          <p:nvSpPr>
+            <p:cNvPr id="10" name="Shape 6"/>
+            <p:cNvSpPr/>
+            <p:nvPr/>
+          </p:nvSpPr>
+          <p:spPr>
+            <a:xfrm>
+              <a:off x="4178260" y="1625679"/>
+              <a:ext cx="2246114" cy="224195"/>
+            </a:xfrm>
+            <a:prstGeom prst="roundRect">
+              <a:avLst>
+                <a:gd name="adj" fmla="val 79940"/>
+              </a:avLst>
+            </a:prstGeom>
+            <a:solidFill>
+              <a:srgbClr val="FFFFFF">
+                <a:alpha val="20000"/>
+              </a:srgbClr>
+            </a:solidFill>
+            <a:ln w="7620">
+              <a:solidFill>
+                <a:srgbClr val="000000"/>
+              </a:solidFill>
+              <a:prstDash val="solid"/>
+            </a:ln>
+          </p:spPr>
+          <p:txBody>
+            <a:bodyPr/>
+            <a:lstStyle/>
+            <a:p>
+              <a:endParaRPr lang="en-US"/>
+            </a:p>
+          </p:txBody>
+        </p:sp>
+        <p:pic>
+          <p:nvPicPr>
+            <p:cNvPr id="11" name="Image 2" descr="preencoded.png"/>
+            <p:cNvPicPr>
+              <a:picLocks noChangeAspect="1"/>
+            </p:cNvPicPr>
+            <p:nvPr/>
+          </p:nvPicPr>
+          <p:blipFill>
+            <a:blip r:embed="rId5"/>
+            <a:stretch>
+              <a:fillRect/>
+            </a:stretch>
+          </p:blipFill>
+          <p:spPr>
+            <a:xfrm>
+              <a:off x="4249817" y="1673781"/>
+              <a:ext cx="127992" cy="127992"/>
+            </a:xfrm>
+            <a:prstGeom prst="rect">
+              <a:avLst/>
+            </a:prstGeom>
+          </p:spPr>
+        </p:pic>
+        <p:sp>
+          <p:nvSpPr>
+            <p:cNvPr id="12" name="Text 7"/>
+            <p:cNvSpPr/>
+            <p:nvPr/>
+          </p:nvSpPr>
+          <p:spPr>
+            <a:xfrm>
+              <a:off x="4420433" y="1654612"/>
+              <a:ext cx="1932384" cy="166330"/>
+            </a:xfrm>
+            <a:prstGeom prst="rect">
+              <a:avLst/>
+            </a:prstGeom>
+            <a:noFill/>
+            <a:ln/>
+          </p:spPr>
+          <p:txBody>
+            <a:bodyPr wrap="none" lIns="0" tIns="0" rIns="0" bIns="0" rtlCol="0" anchor="t"/>
+            <a:lstStyle/>
+            <a:p>
+              <a:pPr marL="0" indent="0" algn="l">
+                <a:lnSpc>
+                  <a:spcPts val="1300"/>
+                </a:lnSpc>
+                <a:buNone/>
+              </a:pPr>
+              <a:r>
+                <a:rPr lang="en-US" sz="1000" dirty="0">
+                  <a:solidFill>
+                    <a:srgbClr val="4C4C4D"/>
+                  </a:solidFill>
+                  <a:latin typeface="-apple-system, BlinkMacSystemFont, Segoe UI, Roboto, Helvetica Neue, Arial, sans-serif Medium" pitchFamily="34" charset="0"/>
+                  <a:ea typeface="-apple-system, BlinkMacSystemFont, Segoe UI, Roboto, Helvetica Neue, Arial, sans-serif Medium" pitchFamily="34" charset="-122"/>
+                  <a:cs typeface="-apple-system, BlinkMacSystemFont, Segoe UI, Roboto, Helvetica Neue, Arial, sans-serif Medium" pitchFamily="34" charset="-120"/>
+                </a:rPr>
+                <a:t>High-Growth Shelby Community</a:t>
+              </a:r>
+              <a:endParaRPr lang="en-US" sz="1000" dirty="0"/>
+            </a:p>
+          </p:txBody>
+        </p:sp>
+      </p:grpSp>
+      <p:grpSp>
+        <p:nvGrpSpPr>
+          <p:cNvPr id="65" name="Group 64">
+            <a:extLst>
+              <a:ext uri="{FF2B5EF4-FFF2-40B4-BE49-F238E27FC236}">
+                <a16:creationId xmlns:a16="http://schemas.microsoft.com/office/drawing/2014/main" id="{97B601EC-DDAD-BDBD-5FEB-8AC4ECE5CFC3}"/>
+              </a:ext>
+            </a:extLst>
+          </p:cNvPr>
+          <p:cNvGrpSpPr/>
+          <p:nvPr/>
+        </p:nvGrpSpPr>
+        <p:grpSpPr>
+          <a:xfrm>
+            <a:off x="733468" y="2175878"/>
+            <a:ext cx="6010232" cy="5214966"/>
+            <a:chOff x="731758" y="1956554"/>
+            <a:chExt cx="6499979" cy="4879777"/>
+          </a:xfrm>
+        </p:grpSpPr>
+        <p:pic>
+          <p:nvPicPr>
+            <p:cNvPr id="13" name="Image 3" descr="preencoded.png"/>
+            <p:cNvPicPr>
+              <a:picLocks noChangeAspect="1"/>
+            </p:cNvPicPr>
+            <p:nvPr/>
+          </p:nvPicPr>
+          <p:blipFill>
+            <a:blip r:embed="rId6"/>
+            <a:stretch>
+              <a:fillRect/>
+            </a:stretch>
+          </p:blipFill>
+          <p:spPr>
+            <a:xfrm>
+              <a:off x="731758" y="1956554"/>
+              <a:ext cx="6499979" cy="4879777"/>
+            </a:xfrm>
+            <a:prstGeom prst="rect">
+              <a:avLst/>
+            </a:prstGeom>
+          </p:spPr>
+        </p:pic>
+        <p:sp>
+          <p:nvSpPr>
+            <p:cNvPr id="14" name="Text 8"/>
+            <p:cNvSpPr/>
+            <p:nvPr/>
+          </p:nvSpPr>
+          <p:spPr>
+            <a:xfrm>
+              <a:off x="1111829" y="2341962"/>
+              <a:ext cx="179903" cy="178356"/>
+            </a:xfrm>
+            <a:prstGeom prst="rect">
+              <a:avLst/>
+            </a:prstGeom>
+            <a:noFill/>
+            <a:ln/>
+          </p:spPr>
+          <p:txBody>
+            <a:bodyPr wrap="none" lIns="30480" tIns="30480" rIns="30480" bIns="30480" rtlCol="0" anchor="t"/>
+            <a:lstStyle/>
+            <a:p>
+              <a:pPr marL="0" indent="0" algn="l">
+                <a:lnSpc>
+                  <a:spcPts val="900"/>
+                </a:lnSpc>
+                <a:buNone/>
+              </a:pPr>
+              <a:r>
+                <a:rPr lang="en-US" sz="900" dirty="0">
+                  <a:solidFill>
+                    <a:srgbClr val="000000"/>
+                  </a:solidFill>
+                  <a:latin typeface="-apple-system, BlinkMacSystemFont, Segoe UI, Roboto, Helvetica Neue, Arial, sans-serif Medium" pitchFamily="34" charset="0"/>
+                  <a:ea typeface="-apple-system, BlinkMacSystemFont, Segoe UI, Roboto, Helvetica Neue, Arial, sans-serif Medium" pitchFamily="34" charset="-122"/>
+                  <a:cs typeface="-apple-system, BlinkMacSystemFont, Segoe UI, Roboto, Helvetica Neue, Arial, sans-serif Medium" pitchFamily="34" charset="-120"/>
+                </a:rPr>
+                <a:t>77</a:t>
+              </a:r>
+              <a:endParaRPr lang="en-US" sz="900" dirty="0"/>
+            </a:p>
+          </p:txBody>
+        </p:sp>
+        <p:sp>
+          <p:nvSpPr>
+            <p:cNvPr id="15" name="Text 9"/>
+            <p:cNvSpPr/>
+            <p:nvPr/>
+          </p:nvSpPr>
+          <p:spPr>
+            <a:xfrm>
+              <a:off x="1508227" y="3340657"/>
+              <a:ext cx="179903" cy="178356"/>
+            </a:xfrm>
+            <a:prstGeom prst="rect">
+              <a:avLst/>
+            </a:prstGeom>
+            <a:noFill/>
+            <a:ln/>
+          </p:spPr>
+          <p:txBody>
+            <a:bodyPr wrap="none" lIns="30480" tIns="30480" rIns="30480" bIns="30480" rtlCol="0" anchor="t"/>
+            <a:lstStyle/>
+            <a:p>
+              <a:pPr marL="0" indent="0" algn="l">
+                <a:lnSpc>
+                  <a:spcPts val="900"/>
+                </a:lnSpc>
+                <a:buNone/>
+              </a:pPr>
+              <a:r>
+                <a:rPr lang="en-US" sz="900" dirty="0">
+                  <a:solidFill>
+                    <a:srgbClr val="000000"/>
+                  </a:solidFill>
+                  <a:latin typeface="-apple-system, BlinkMacSystemFont, Segoe UI, Roboto, Helvetica Neue, Arial, sans-serif Medium" pitchFamily="34" charset="0"/>
+                  <a:ea typeface="-apple-system, BlinkMacSystemFont, Segoe UI, Roboto, Helvetica Neue, Arial, sans-serif Medium" pitchFamily="34" charset="-122"/>
+                  <a:cs typeface="-apple-system, BlinkMacSystemFont, Segoe UI, Roboto, Helvetica Neue, Arial, sans-serif Medium" pitchFamily="34" charset="-120"/>
+                </a:rPr>
+                <a:t>58</a:t>
+              </a:r>
+              <a:endParaRPr lang="en-US" sz="900" dirty="0"/>
+            </a:p>
+          </p:txBody>
+        </p:sp>
+        <p:sp>
+          <p:nvSpPr>
+            <p:cNvPr id="16" name="Text 10"/>
+            <p:cNvSpPr/>
+            <p:nvPr/>
+          </p:nvSpPr>
+          <p:spPr>
+            <a:xfrm>
+              <a:off x="1904625" y="5075234"/>
+              <a:ext cx="179903" cy="178356"/>
+            </a:xfrm>
+            <a:prstGeom prst="rect">
+              <a:avLst/>
+            </a:prstGeom>
+            <a:noFill/>
+            <a:ln/>
+          </p:spPr>
+          <p:txBody>
+            <a:bodyPr wrap="none" lIns="30480" tIns="30480" rIns="30480" bIns="30480" rtlCol="0" anchor="t"/>
+            <a:lstStyle/>
+            <a:p>
+              <a:pPr marL="0" indent="0" algn="l">
+                <a:lnSpc>
+                  <a:spcPts val="900"/>
+                </a:lnSpc>
+                <a:buNone/>
+              </a:pPr>
+              <a:r>
+                <a:rPr lang="en-US" sz="900" dirty="0">
+                  <a:solidFill>
+                    <a:srgbClr val="000000"/>
+                  </a:solidFill>
+                  <a:latin typeface="-apple-system, BlinkMacSystemFont, Segoe UI, Roboto, Helvetica Neue, Arial, sans-serif Medium" pitchFamily="34" charset="0"/>
+                  <a:ea typeface="-apple-system, BlinkMacSystemFont, Segoe UI, Roboto, Helvetica Neue, Arial, sans-serif Medium" pitchFamily="34" charset="-122"/>
+                  <a:cs typeface="-apple-system, BlinkMacSystemFont, Segoe UI, Roboto, Helvetica Neue, Arial, sans-serif Medium" pitchFamily="34" charset="-120"/>
+                </a:rPr>
+                <a:t>25</a:t>
+              </a:r>
+              <a:endParaRPr lang="en-US" sz="900" dirty="0"/>
+            </a:p>
+          </p:txBody>
+        </p:sp>
+        <p:sp>
+          <p:nvSpPr>
+            <p:cNvPr id="17" name="Text 11"/>
+            <p:cNvSpPr/>
+            <p:nvPr/>
+          </p:nvSpPr>
+          <p:spPr>
+            <a:xfrm>
+              <a:off x="2661790" y="5548300"/>
+              <a:ext cx="179903" cy="178356"/>
+            </a:xfrm>
+            <a:prstGeom prst="rect">
+              <a:avLst/>
+            </a:prstGeom>
+            <a:noFill/>
+            <a:ln/>
+          </p:spPr>
+          <p:txBody>
+            <a:bodyPr wrap="none" lIns="30480" tIns="30480" rIns="30480" bIns="30480" rtlCol="0" anchor="t"/>
+            <a:lstStyle/>
+            <a:p>
+              <a:pPr marL="0" indent="0" algn="l">
+                <a:lnSpc>
+                  <a:spcPts val="900"/>
+                </a:lnSpc>
+                <a:buNone/>
+              </a:pPr>
+              <a:r>
+                <a:rPr lang="en-US" sz="900" dirty="0">
+                  <a:solidFill>
+                    <a:srgbClr val="000000"/>
+                  </a:solidFill>
+                  <a:latin typeface="-apple-system, BlinkMacSystemFont, Segoe UI, Roboto, Helvetica Neue, Arial, sans-serif Medium" pitchFamily="34" charset="0"/>
+                  <a:ea typeface="-apple-system, BlinkMacSystemFont, Segoe UI, Roboto, Helvetica Neue, Arial, sans-serif Medium" pitchFamily="34" charset="-122"/>
+                  <a:cs typeface="-apple-system, BlinkMacSystemFont, Segoe UI, Roboto, Helvetica Neue, Arial, sans-serif Medium" pitchFamily="34" charset="-120"/>
+                </a:rPr>
+                <a:t>16</a:t>
+              </a:r>
+              <a:endParaRPr lang="en-US" sz="900" dirty="0"/>
+            </a:p>
+          </p:txBody>
+        </p:sp>
+        <p:sp>
+          <p:nvSpPr>
+            <p:cNvPr id="18" name="Text 12"/>
+            <p:cNvSpPr/>
+            <p:nvPr/>
+          </p:nvSpPr>
+          <p:spPr>
+            <a:xfrm>
+              <a:off x="3058188" y="4970108"/>
+              <a:ext cx="179903" cy="178356"/>
+            </a:xfrm>
+            <a:prstGeom prst="rect">
+              <a:avLst/>
+            </a:prstGeom>
+            <a:noFill/>
+            <a:ln/>
+          </p:spPr>
+          <p:txBody>
+            <a:bodyPr wrap="none" lIns="30480" tIns="30480" rIns="30480" bIns="30480" rtlCol="0" anchor="t"/>
+            <a:lstStyle/>
+            <a:p>
+              <a:pPr marL="0" indent="0" algn="l">
+                <a:lnSpc>
+                  <a:spcPts val="900"/>
+                </a:lnSpc>
+                <a:buNone/>
+              </a:pPr>
+              <a:r>
+                <a:rPr lang="en-US" sz="900" dirty="0">
+                  <a:solidFill>
+                    <a:srgbClr val="000000"/>
+                  </a:solidFill>
+                  <a:latin typeface="-apple-system, BlinkMacSystemFont, Segoe UI, Roboto, Helvetica Neue, Arial, sans-serif Medium" pitchFamily="34" charset="0"/>
+                  <a:ea typeface="-apple-system, BlinkMacSystemFont, Segoe UI, Roboto, Helvetica Neue, Arial, sans-serif Medium" pitchFamily="34" charset="-122"/>
+                  <a:cs typeface="-apple-system, BlinkMacSystemFont, Segoe UI, Roboto, Helvetica Neue, Arial, sans-serif Medium" pitchFamily="34" charset="-120"/>
+                </a:rPr>
+                <a:t>27</a:t>
+              </a:r>
+              <a:endParaRPr lang="en-US" sz="900" dirty="0"/>
+            </a:p>
+          </p:txBody>
+        </p:sp>
+        <p:sp>
+          <p:nvSpPr>
+            <p:cNvPr id="19" name="Text 13"/>
+            <p:cNvSpPr/>
+            <p:nvPr/>
+          </p:nvSpPr>
+          <p:spPr>
+            <a:xfrm>
+              <a:off x="3454586" y="3077843"/>
+              <a:ext cx="179903" cy="178356"/>
+            </a:xfrm>
+            <a:prstGeom prst="rect">
+              <a:avLst/>
+            </a:prstGeom>
+            <a:noFill/>
+            <a:ln/>
+          </p:spPr>
+          <p:txBody>
+            <a:bodyPr wrap="none" lIns="30480" tIns="30480" rIns="30480" bIns="30480" rtlCol="0" anchor="t"/>
+            <a:lstStyle/>
+            <a:p>
+              <a:pPr marL="0" indent="0" algn="l">
+                <a:lnSpc>
+                  <a:spcPts val="900"/>
+                </a:lnSpc>
+                <a:buNone/>
+              </a:pPr>
+              <a:r>
+                <a:rPr lang="en-US" sz="900" dirty="0">
+                  <a:solidFill>
+                    <a:srgbClr val="000000"/>
+                  </a:solidFill>
+                  <a:latin typeface="-apple-system, BlinkMacSystemFont, Segoe UI, Roboto, Helvetica Neue, Arial, sans-serif Medium" pitchFamily="34" charset="0"/>
+                  <a:ea typeface="-apple-system, BlinkMacSystemFont, Segoe UI, Roboto, Helvetica Neue, Arial, sans-serif Medium" pitchFamily="34" charset="-122"/>
+                  <a:cs typeface="-apple-system, BlinkMacSystemFont, Segoe UI, Roboto, Helvetica Neue, Arial, sans-serif Medium" pitchFamily="34" charset="-120"/>
+                </a:rPr>
+                <a:t>63</a:t>
+              </a:r>
+              <a:endParaRPr lang="en-US" sz="900" dirty="0"/>
+            </a:p>
+          </p:txBody>
+        </p:sp>
+        <p:sp>
+          <p:nvSpPr>
+            <p:cNvPr id="20" name="Text 14"/>
+            <p:cNvSpPr/>
+            <p:nvPr/>
+          </p:nvSpPr>
+          <p:spPr>
+            <a:xfrm>
+              <a:off x="4245267" y="6097667"/>
+              <a:ext cx="112871" cy="178356"/>
+            </a:xfrm>
+            <a:prstGeom prst="rect">
+              <a:avLst/>
+            </a:prstGeom>
+            <a:noFill/>
+            <a:ln/>
+          </p:spPr>
+          <p:txBody>
+            <a:bodyPr wrap="none" lIns="30480" tIns="30480" rIns="30480" bIns="30480" rtlCol="0" anchor="t"/>
+            <a:lstStyle/>
+            <a:p>
+              <a:pPr marL="0" indent="0" algn="l">
+                <a:lnSpc>
+                  <a:spcPts val="900"/>
+                </a:lnSpc>
+                <a:buNone/>
+              </a:pPr>
+              <a:r>
+                <a:rPr lang="en-US" sz="900" dirty="0">
+                  <a:solidFill>
+                    <a:srgbClr val="000000"/>
+                  </a:solidFill>
+                  <a:latin typeface="-apple-system, BlinkMacSystemFont, Segoe UI, Roboto, Helvetica Neue, Arial, sans-serif Medium" pitchFamily="34" charset="0"/>
+                  <a:ea typeface="-apple-system, BlinkMacSystemFont, Segoe UI, Roboto, Helvetica Neue, Arial, sans-serif Medium" pitchFamily="34" charset="-122"/>
+                  <a:cs typeface="-apple-system, BlinkMacSystemFont, Segoe UI, Roboto, Helvetica Neue, Arial, sans-serif Medium" pitchFamily="34" charset="-120"/>
+                </a:rPr>
+                <a:t>1</a:t>
+              </a:r>
+              <a:endParaRPr lang="en-US" sz="900" dirty="0"/>
+            </a:p>
+          </p:txBody>
+        </p:sp>
+        <p:sp>
+          <p:nvSpPr>
+            <p:cNvPr id="21" name="Text 15"/>
+            <p:cNvSpPr/>
+            <p:nvPr/>
+          </p:nvSpPr>
+          <p:spPr>
+            <a:xfrm>
+              <a:off x="4641666" y="6045105"/>
+              <a:ext cx="112871" cy="178356"/>
+            </a:xfrm>
+            <a:prstGeom prst="rect">
+              <a:avLst/>
+            </a:prstGeom>
+            <a:noFill/>
+            <a:ln/>
+          </p:spPr>
+          <p:txBody>
+            <a:bodyPr wrap="none" lIns="30480" tIns="30480" rIns="30480" bIns="30480" rtlCol="0" anchor="t"/>
+            <a:lstStyle/>
+            <a:p>
+              <a:pPr marL="0" indent="0" algn="l">
+                <a:lnSpc>
+                  <a:spcPts val="900"/>
+                </a:lnSpc>
+                <a:buNone/>
+              </a:pPr>
+              <a:r>
+                <a:rPr lang="en-US" sz="900" dirty="0">
+                  <a:solidFill>
+                    <a:srgbClr val="000000"/>
+                  </a:solidFill>
+                  <a:latin typeface="-apple-system, BlinkMacSystemFont, Segoe UI, Roboto, Helvetica Neue, Arial, sans-serif Medium" pitchFamily="34" charset="0"/>
+                  <a:ea typeface="-apple-system, BlinkMacSystemFont, Segoe UI, Roboto, Helvetica Neue, Arial, sans-serif Medium" pitchFamily="34" charset="-122"/>
+                  <a:cs typeface="-apple-system, BlinkMacSystemFont, Segoe UI, Roboto, Helvetica Neue, Arial, sans-serif Medium" pitchFamily="34" charset="-120"/>
+                </a:rPr>
+                <a:t>2</a:t>
+              </a:r>
+              <a:endParaRPr lang="en-US" sz="900" dirty="0"/>
+            </a:p>
+          </p:txBody>
+        </p:sp>
+        <p:sp>
+          <p:nvSpPr>
+            <p:cNvPr id="22" name="Text 16"/>
+            <p:cNvSpPr/>
+            <p:nvPr/>
+          </p:nvSpPr>
+          <p:spPr>
+            <a:xfrm>
+              <a:off x="5038064" y="6073930"/>
+              <a:ext cx="112871" cy="178356"/>
+            </a:xfrm>
+            <a:prstGeom prst="rect">
+              <a:avLst/>
+            </a:prstGeom>
+            <a:noFill/>
+            <a:ln/>
+          </p:spPr>
+          <p:txBody>
+            <a:bodyPr wrap="none" lIns="30480" tIns="30480" rIns="30480" bIns="30480" rtlCol="0" anchor="t"/>
+            <a:lstStyle/>
+            <a:p>
+              <a:pPr marL="0" indent="0" algn="l">
+                <a:lnSpc>
+                  <a:spcPts val="900"/>
+                </a:lnSpc>
+                <a:buNone/>
+              </a:pPr>
+              <a:r>
+                <a:rPr lang="en-US" sz="900" dirty="0">
+                  <a:solidFill>
+                    <a:srgbClr val="000000"/>
+                  </a:solidFill>
+                  <a:latin typeface="-apple-system, BlinkMacSystemFont, Segoe UI, Roboto, Helvetica Neue, Arial, sans-serif Medium" pitchFamily="34" charset="0"/>
+                  <a:ea typeface="-apple-system, BlinkMacSystemFont, Segoe UI, Roboto, Helvetica Neue, Arial, sans-serif Medium" pitchFamily="34" charset="-122"/>
+                  <a:cs typeface="-apple-system, BlinkMacSystemFont, Segoe UI, Roboto, Helvetica Neue, Arial, sans-serif Medium" pitchFamily="34" charset="-120"/>
+                </a:rPr>
+                <a:t>6</a:t>
+              </a:r>
+              <a:endParaRPr lang="en-US" sz="900" dirty="0"/>
+            </a:p>
+          </p:txBody>
+        </p:sp>
+        <p:sp>
+          <p:nvSpPr>
+            <p:cNvPr id="23" name="Text 17"/>
+            <p:cNvSpPr/>
+            <p:nvPr/>
+          </p:nvSpPr>
+          <p:spPr>
+            <a:xfrm>
+              <a:off x="5795229" y="6021367"/>
+              <a:ext cx="112871" cy="178356"/>
+            </a:xfrm>
+            <a:prstGeom prst="rect">
+              <a:avLst/>
+            </a:prstGeom>
+            <a:noFill/>
+            <a:ln/>
+          </p:spPr>
+          <p:txBody>
+            <a:bodyPr wrap="none" lIns="30480" tIns="30480" rIns="30480" bIns="30480" rtlCol="0" anchor="t"/>
+            <a:lstStyle/>
+            <a:p>
+              <a:pPr marL="0" indent="0" algn="l">
+                <a:lnSpc>
+                  <a:spcPts val="900"/>
+                </a:lnSpc>
+                <a:buNone/>
+              </a:pPr>
+              <a:r>
+                <a:rPr lang="en-US" sz="900" dirty="0">
+                  <a:solidFill>
+                    <a:srgbClr val="000000"/>
+                  </a:solidFill>
+                  <a:latin typeface="-apple-system, BlinkMacSystemFont, Segoe UI, Roboto, Helvetica Neue, Arial, sans-serif Medium" pitchFamily="34" charset="0"/>
+                  <a:ea typeface="-apple-system, BlinkMacSystemFont, Segoe UI, Roboto, Helvetica Neue, Arial, sans-serif Medium" pitchFamily="34" charset="-122"/>
+                  <a:cs typeface="-apple-system, BlinkMacSystemFont, Segoe UI, Roboto, Helvetica Neue, Arial, sans-serif Medium" pitchFamily="34" charset="-120"/>
+                </a:rPr>
+                <a:t>7</a:t>
+              </a:r>
+              <a:endParaRPr lang="en-US" sz="900" dirty="0"/>
+            </a:p>
+          </p:txBody>
+        </p:sp>
+        <p:sp>
+          <p:nvSpPr>
+            <p:cNvPr id="24" name="Text 18"/>
+            <p:cNvSpPr/>
+            <p:nvPr/>
+          </p:nvSpPr>
+          <p:spPr>
+            <a:xfrm>
+              <a:off x="6158111" y="5705989"/>
+              <a:ext cx="179903" cy="178356"/>
+            </a:xfrm>
+            <a:prstGeom prst="rect">
+              <a:avLst/>
+            </a:prstGeom>
+            <a:noFill/>
+            <a:ln/>
+          </p:spPr>
+          <p:txBody>
+            <a:bodyPr wrap="none" lIns="30480" tIns="30480" rIns="30480" bIns="30480" rtlCol="0" anchor="t"/>
+            <a:lstStyle/>
+            <a:p>
+              <a:pPr marL="0" indent="0" algn="l">
+                <a:lnSpc>
+                  <a:spcPts val="900"/>
+                </a:lnSpc>
+                <a:buNone/>
+              </a:pPr>
+              <a:r>
+                <a:rPr lang="en-US" sz="900" dirty="0">
+                  <a:solidFill>
+                    <a:srgbClr val="000000"/>
+                  </a:solidFill>
+                  <a:latin typeface="-apple-system, BlinkMacSystemFont, Segoe UI, Roboto, Helvetica Neue, Arial, sans-serif Medium" pitchFamily="34" charset="0"/>
+                  <a:ea typeface="-apple-system, BlinkMacSystemFont, Segoe UI, Roboto, Helvetica Neue, Arial, sans-serif Medium" pitchFamily="34" charset="-122"/>
+                  <a:cs typeface="-apple-system, BlinkMacSystemFont, Segoe UI, Roboto, Helvetica Neue, Arial, sans-serif Medium" pitchFamily="34" charset="-120"/>
+                </a:rPr>
+                <a:t>13</a:t>
+              </a:r>
+              <a:endParaRPr lang="en-US" sz="900" dirty="0"/>
+            </a:p>
+          </p:txBody>
+        </p:sp>
+        <p:sp>
+          <p:nvSpPr>
+            <p:cNvPr id="25" name="Text 19"/>
+            <p:cNvSpPr/>
+            <p:nvPr/>
+          </p:nvSpPr>
+          <p:spPr>
+            <a:xfrm>
+              <a:off x="6588025" y="6073930"/>
+              <a:ext cx="112871" cy="178356"/>
+            </a:xfrm>
+            <a:prstGeom prst="rect">
+              <a:avLst/>
+            </a:prstGeom>
+            <a:noFill/>
+            <a:ln/>
+          </p:spPr>
+          <p:txBody>
+            <a:bodyPr wrap="none" lIns="30480" tIns="30480" rIns="30480" bIns="30480" rtlCol="0" anchor="t"/>
+            <a:lstStyle/>
+            <a:p>
+              <a:pPr marL="0" indent="0" algn="l">
+                <a:lnSpc>
+                  <a:spcPts val="900"/>
+                </a:lnSpc>
+                <a:buNone/>
+              </a:pPr>
+              <a:r>
+                <a:rPr lang="en-US" sz="900" dirty="0">
+                  <a:solidFill>
+                    <a:srgbClr val="000000"/>
+                  </a:solidFill>
+                  <a:latin typeface="-apple-system, BlinkMacSystemFont, Segoe UI, Roboto, Helvetica Neue, Arial, sans-serif Medium" pitchFamily="34" charset="0"/>
+                  <a:ea typeface="-apple-system, BlinkMacSystemFont, Segoe UI, Roboto, Helvetica Neue, Arial, sans-serif Medium" pitchFamily="34" charset="-122"/>
+                  <a:cs typeface="-apple-system, BlinkMacSystemFont, Segoe UI, Roboto, Helvetica Neue, Arial, sans-serif Medium" pitchFamily="34" charset="-120"/>
+                </a:rPr>
+                <a:t>6</a:t>
+              </a:r>
+              <a:endParaRPr lang="en-US" sz="900" dirty="0"/>
+            </a:p>
+          </p:txBody>
+        </p:sp>
+      </p:grpSp>
+      <p:sp>
+        <p:nvSpPr>
+          <p:cNvPr id="27" name="Text 20"/>
+          <p:cNvSpPr/>
+          <p:nvPr/>
+        </p:nvSpPr>
+        <p:spPr>
+          <a:xfrm>
+            <a:off x="9892838" y="5854060"/>
+            <a:ext cx="1805821" cy="212288"/>
+          </a:xfrm>
+          <a:prstGeom prst="rect">
+            <a:avLst/>
+          </a:prstGeom>
+          <a:noFill/>
+          <a:ln/>
+        </p:spPr>
+        <p:txBody>
+          <a:bodyPr wrap="none" lIns="0" tIns="0" rIns="0" bIns="0" rtlCol="0" anchor="t"/>
+          <a:lstStyle/>
+          <a:p>
+            <a:pPr marL="0" indent="0" algn="l">
+              <a:lnSpc>
+                <a:spcPts val="1650"/>
+              </a:lnSpc>
+              <a:buNone/>
+            </a:pPr>
+            <a:r>
+              <a:rPr lang="en-US" sz="1300" dirty="0">
+                <a:solidFill>
+                  <a:srgbClr val="152D47"/>
+                </a:solidFill>
+                <a:latin typeface="Crimson Pro Semi Bold" pitchFamily="34" charset="0"/>
+                <a:ea typeface="Crimson Pro Semi Bold" pitchFamily="34" charset="-122"/>
+                <a:cs typeface="Crimson Pro Semi Bold" pitchFamily="34" charset="-120"/>
+              </a:rPr>
+              <a:t>Whitehaven ZIPs of Focus</a:t>
+            </a:r>
+            <a:endParaRPr lang="en-US" sz="1300" dirty="0"/>
+          </a:p>
+        </p:txBody>
+      </p:sp>
+      <p:grpSp>
+        <p:nvGrpSpPr>
+          <p:cNvPr id="68" name="Group 67">
+            <a:extLst>
+              <a:ext uri="{FF2B5EF4-FFF2-40B4-BE49-F238E27FC236}">
+                <a16:creationId xmlns:a16="http://schemas.microsoft.com/office/drawing/2014/main" id="{292B24DA-4D16-4545-F491-6C19A391956E}"/>
+              </a:ext>
+            </a:extLst>
+          </p:cNvPr>
+          <p:cNvGrpSpPr/>
+          <p:nvPr/>
+        </p:nvGrpSpPr>
+        <p:grpSpPr>
+          <a:xfrm>
+            <a:off x="7519686" y="6158600"/>
+            <a:ext cx="6492734" cy="1204910"/>
+            <a:chOff x="8171855" y="5124807"/>
+            <a:chExt cx="5742742" cy="1335881"/>
+          </a:xfrm>
+        </p:grpSpPr>
+        <p:sp>
+          <p:nvSpPr>
+            <p:cNvPr id="28" name="Shape 21"/>
+            <p:cNvSpPr/>
+            <p:nvPr/>
+          </p:nvSpPr>
+          <p:spPr>
+            <a:xfrm>
+              <a:off x="8171855" y="5124807"/>
+              <a:ext cx="5742742" cy="1335881"/>
+            </a:xfrm>
+            <a:prstGeom prst="roundRect">
+              <a:avLst>
+                <a:gd name="adj" fmla="val 1526"/>
+              </a:avLst>
+            </a:prstGeom>
+            <a:noFill/>
+            <a:ln w="7620">
+              <a:solidFill>
+                <a:srgbClr val="000000">
+                  <a:alpha val="8000"/>
+                </a:srgbClr>
+              </a:solidFill>
+              <a:prstDash val="solid"/>
+            </a:ln>
+          </p:spPr>
+          <p:txBody>
+            <a:bodyPr/>
+            <a:lstStyle/>
+            <a:p>
+              <a:endParaRPr lang="en-US"/>
+            </a:p>
+          </p:txBody>
+        </p:sp>
+        <p:grpSp>
+          <p:nvGrpSpPr>
+            <p:cNvPr id="67" name="Group 66">
+              <a:extLst>
+                <a:ext uri="{FF2B5EF4-FFF2-40B4-BE49-F238E27FC236}">
+                  <a16:creationId xmlns:a16="http://schemas.microsoft.com/office/drawing/2014/main" id="{C110388D-D6C4-F0C5-0D60-7D8DE487E249}"/>
+                </a:ext>
+              </a:extLst>
+            </p:cNvPr>
+            <p:cNvGrpSpPr/>
+            <p:nvPr/>
+          </p:nvGrpSpPr>
+          <p:grpSpPr>
+            <a:xfrm>
+              <a:off x="8480703" y="5200630"/>
+              <a:ext cx="5125045" cy="1070252"/>
+              <a:chOff x="8179475" y="5132427"/>
+              <a:chExt cx="5726907" cy="1320640"/>
+            </a:xfrm>
+          </p:grpSpPr>
+          <p:sp>
+            <p:nvSpPr>
+              <p:cNvPr id="29" name="Shape 22"/>
+              <p:cNvSpPr/>
+              <p:nvPr/>
+            </p:nvSpPr>
+            <p:spPr>
+              <a:xfrm>
+                <a:off x="8179475" y="5132427"/>
+                <a:ext cx="5726906" cy="330160"/>
+              </a:xfrm>
+              <a:prstGeom prst="rect">
+                <a:avLst/>
+              </a:prstGeom>
+              <a:solidFill>
+                <a:srgbClr val="FFFFFF">
+                  <a:alpha val="4000"/>
+                </a:srgbClr>
+              </a:solidFill>
+              <a:ln/>
+            </p:spPr>
+            <p:txBody>
+              <a:bodyPr/>
+              <a:lstStyle/>
+              <a:p>
+                <a:endParaRPr lang="en-US"/>
+              </a:p>
+            </p:txBody>
+          </p:sp>
+          <p:sp>
+            <p:nvSpPr>
+              <p:cNvPr id="30" name="Text 23"/>
+              <p:cNvSpPr/>
+              <p:nvPr/>
+            </p:nvSpPr>
+            <p:spPr>
+              <a:xfrm>
+                <a:off x="8316159" y="5188862"/>
+                <a:ext cx="1633180" cy="217289"/>
+              </a:xfrm>
+              <a:prstGeom prst="rect">
+                <a:avLst/>
+              </a:prstGeom>
+              <a:noFill/>
+              <a:ln/>
+            </p:spPr>
+            <p:txBody>
+              <a:bodyPr wrap="none" lIns="0" tIns="0" rIns="0" bIns="0" rtlCol="0" anchor="t"/>
+              <a:lstStyle/>
+              <a:p>
+                <a:pPr marL="0" indent="0" algn="l">
+                  <a:lnSpc>
+                    <a:spcPts val="1700"/>
+                  </a:lnSpc>
+                  <a:buNone/>
+                </a:pPr>
+                <a:r>
+                  <a:rPr lang="en-US" sz="1300" b="1" dirty="0">
+                    <a:solidFill>
+                      <a:srgbClr val="4C4C4D"/>
+                    </a:solidFill>
+                    <a:latin typeface="Heebo" pitchFamily="34" charset="0"/>
+                    <a:ea typeface="Heebo" pitchFamily="34" charset="-122"/>
+                    <a:cs typeface="Heebo" pitchFamily="34" charset="-120"/>
+                  </a:rPr>
+                  <a:t>ZIP</a:t>
+                </a:r>
+                <a:endParaRPr lang="en-US" sz="1300" dirty="0"/>
+              </a:p>
+            </p:txBody>
+          </p:sp>
+          <p:sp>
+            <p:nvSpPr>
+              <p:cNvPr id="31" name="Text 24"/>
+              <p:cNvSpPr/>
+              <p:nvPr/>
+            </p:nvSpPr>
+            <p:spPr>
+              <a:xfrm>
+                <a:off x="10228660" y="5188862"/>
+                <a:ext cx="1629370" cy="217289"/>
+              </a:xfrm>
+              <a:prstGeom prst="rect">
+                <a:avLst/>
+              </a:prstGeom>
+              <a:noFill/>
+              <a:ln/>
+            </p:spPr>
+            <p:txBody>
+              <a:bodyPr wrap="none" lIns="0" tIns="0" rIns="0" bIns="0" rtlCol="0" anchor="t"/>
+              <a:lstStyle/>
+              <a:p>
+                <a:pPr marL="0" indent="0" algn="l">
+                  <a:lnSpc>
+                    <a:spcPts val="1700"/>
+                  </a:lnSpc>
+                  <a:buNone/>
+                </a:pPr>
+                <a:r>
+                  <a:rPr lang="en-US" sz="1300" b="1" dirty="0">
+                    <a:solidFill>
+                      <a:srgbClr val="4C4C4D"/>
+                    </a:solidFill>
+                    <a:latin typeface="Heebo" pitchFamily="34" charset="0"/>
+                    <a:ea typeface="Heebo" pitchFamily="34" charset="-122"/>
+                    <a:cs typeface="Heebo" pitchFamily="34" charset="-120"/>
+                  </a:rPr>
+                  <a:t>Population</a:t>
+                </a:r>
+                <a:endParaRPr lang="en-US" sz="1300" dirty="0"/>
+              </a:p>
+            </p:txBody>
+          </p:sp>
+          <p:sp>
+            <p:nvSpPr>
+              <p:cNvPr id="32" name="Text 25"/>
+              <p:cNvSpPr/>
+              <p:nvPr/>
+            </p:nvSpPr>
+            <p:spPr>
+              <a:xfrm>
+                <a:off x="12137351" y="5188862"/>
+                <a:ext cx="1633180" cy="217289"/>
+              </a:xfrm>
+              <a:prstGeom prst="rect">
+                <a:avLst/>
+              </a:prstGeom>
+              <a:noFill/>
+              <a:ln/>
+            </p:spPr>
+            <p:txBody>
+              <a:bodyPr wrap="none" lIns="0" tIns="0" rIns="0" bIns="0" rtlCol="0" anchor="t"/>
+              <a:lstStyle/>
+              <a:p>
+                <a:pPr marL="0" indent="0" algn="l">
+                  <a:lnSpc>
+                    <a:spcPts val="1700"/>
+                  </a:lnSpc>
+                  <a:buNone/>
+                </a:pPr>
+                <a:r>
+                  <a:rPr lang="en-US" sz="1300" b="1" dirty="0">
+                    <a:solidFill>
+                      <a:srgbClr val="4C4C4D"/>
+                    </a:solidFill>
+                    <a:latin typeface="Heebo" pitchFamily="34" charset="0"/>
+                    <a:ea typeface="Heebo" pitchFamily="34" charset="-122"/>
+                    <a:cs typeface="Heebo" pitchFamily="34" charset="-120"/>
+                  </a:rPr>
+                  <a:t>Area</a:t>
+                </a:r>
+                <a:endParaRPr lang="en-US" sz="1300" dirty="0"/>
+              </a:p>
+            </p:txBody>
+          </p:sp>
+          <p:sp>
+            <p:nvSpPr>
+              <p:cNvPr id="33" name="Shape 26"/>
+              <p:cNvSpPr/>
+              <p:nvPr/>
+            </p:nvSpPr>
+            <p:spPr>
+              <a:xfrm>
+                <a:off x="8179475" y="5462587"/>
+                <a:ext cx="5726906" cy="330160"/>
+              </a:xfrm>
+              <a:prstGeom prst="rect">
+                <a:avLst/>
+              </a:prstGeom>
+              <a:solidFill>
+                <a:srgbClr val="000000">
+                  <a:alpha val="4000"/>
+                </a:srgbClr>
+              </a:solidFill>
+              <a:ln/>
+            </p:spPr>
+            <p:txBody>
+              <a:bodyPr/>
+              <a:lstStyle/>
+              <a:p>
+                <a:endParaRPr lang="en-US"/>
+              </a:p>
+            </p:txBody>
+          </p:sp>
+          <p:sp>
+            <p:nvSpPr>
+              <p:cNvPr id="34" name="Shape 27"/>
+              <p:cNvSpPr/>
+              <p:nvPr/>
+            </p:nvSpPr>
+            <p:spPr>
+              <a:xfrm>
+                <a:off x="8180309" y="5462587"/>
+                <a:ext cx="1908691" cy="330160"/>
+              </a:xfrm>
+              <a:prstGeom prst="rect">
+                <a:avLst/>
+              </a:prstGeom>
+              <a:solidFill>
+                <a:srgbClr val="FAA1A1"/>
+              </a:solidFill>
+              <a:ln/>
+            </p:spPr>
+            <p:txBody>
+              <a:bodyPr/>
+              <a:lstStyle/>
+              <a:p>
+                <a:endParaRPr lang="en-US"/>
+              </a:p>
+            </p:txBody>
+          </p:sp>
+          <p:sp>
+            <p:nvSpPr>
+              <p:cNvPr id="35" name="Text 28"/>
+              <p:cNvSpPr/>
+              <p:nvPr/>
+            </p:nvSpPr>
+            <p:spPr>
+              <a:xfrm>
+                <a:off x="8316159" y="5519022"/>
+                <a:ext cx="1633180" cy="217289"/>
+              </a:xfrm>
+              <a:prstGeom prst="rect">
+                <a:avLst/>
+              </a:prstGeom>
+              <a:noFill/>
+              <a:ln/>
+            </p:spPr>
+            <p:txBody>
+              <a:bodyPr wrap="none" lIns="0" tIns="0" rIns="0" bIns="0" rtlCol="0" anchor="t"/>
+              <a:lstStyle/>
+              <a:p>
+                <a:pPr marL="0" indent="0" algn="l">
+                  <a:lnSpc>
+                    <a:spcPts val="1700"/>
+                  </a:lnSpc>
+                  <a:buNone/>
+                </a:pPr>
+                <a:r>
+                  <a:rPr lang="en-US" sz="1300" dirty="0">
+                    <a:solidFill>
+                      <a:srgbClr val="272525"/>
+                    </a:solidFill>
+                    <a:latin typeface="Heebo" pitchFamily="34" charset="0"/>
+                    <a:ea typeface="Heebo" pitchFamily="34" charset="-122"/>
+                    <a:cs typeface="Heebo" pitchFamily="34" charset="-120"/>
+                  </a:rPr>
+                  <a:t>38109</a:t>
+                </a:r>
+                <a:endParaRPr lang="en-US" sz="1300" dirty="0"/>
+              </a:p>
+            </p:txBody>
+          </p:sp>
+          <p:sp>
+            <p:nvSpPr>
+              <p:cNvPr id="36" name="Shape 29"/>
+              <p:cNvSpPr/>
+              <p:nvPr/>
+            </p:nvSpPr>
+            <p:spPr>
+              <a:xfrm>
+                <a:off x="10089000" y="5462587"/>
+                <a:ext cx="1908691" cy="330160"/>
+              </a:xfrm>
+              <a:prstGeom prst="rect">
+                <a:avLst/>
+              </a:prstGeom>
+              <a:solidFill>
+                <a:srgbClr val="FAA1A1"/>
+              </a:solidFill>
+              <a:ln/>
+            </p:spPr>
+            <p:txBody>
+              <a:bodyPr/>
+              <a:lstStyle/>
+              <a:p>
+                <a:endParaRPr lang="en-US"/>
+              </a:p>
+            </p:txBody>
+          </p:sp>
+          <p:sp>
+            <p:nvSpPr>
+              <p:cNvPr id="37" name="Text 30"/>
+              <p:cNvSpPr/>
+              <p:nvPr/>
+            </p:nvSpPr>
+            <p:spPr>
+              <a:xfrm>
+                <a:off x="10228660" y="5519022"/>
+                <a:ext cx="1629370" cy="217289"/>
+              </a:xfrm>
+              <a:prstGeom prst="rect">
+                <a:avLst/>
+              </a:prstGeom>
+              <a:noFill/>
+              <a:ln/>
+            </p:spPr>
+            <p:txBody>
+              <a:bodyPr wrap="none" lIns="0" tIns="0" rIns="0" bIns="0" rtlCol="0" anchor="t"/>
+              <a:lstStyle/>
+              <a:p>
+                <a:pPr marL="0" indent="0" algn="l">
+                  <a:lnSpc>
+                    <a:spcPts val="1700"/>
+                  </a:lnSpc>
+                  <a:buNone/>
+                </a:pPr>
+                <a:r>
+                  <a:rPr lang="en-US" sz="1300" dirty="0">
+                    <a:solidFill>
+                      <a:srgbClr val="272525"/>
+                    </a:solidFill>
+                    <a:latin typeface="Heebo" pitchFamily="34" charset="0"/>
+                    <a:ea typeface="Heebo" pitchFamily="34" charset="-122"/>
+                    <a:cs typeface="Heebo" pitchFamily="34" charset="-120"/>
+                  </a:rPr>
+                  <a:t>~50K</a:t>
+                </a:r>
+                <a:endParaRPr lang="en-US" sz="1300" dirty="0"/>
+              </a:p>
+            </p:txBody>
+          </p:sp>
+          <p:sp>
+            <p:nvSpPr>
+              <p:cNvPr id="38" name="Shape 31"/>
+              <p:cNvSpPr/>
+              <p:nvPr/>
+            </p:nvSpPr>
+            <p:spPr>
+              <a:xfrm>
+                <a:off x="11997691" y="5462587"/>
+                <a:ext cx="1908691" cy="330160"/>
+              </a:xfrm>
+              <a:prstGeom prst="rect">
+                <a:avLst/>
+              </a:prstGeom>
+              <a:solidFill>
+                <a:srgbClr val="FAA1A1"/>
+              </a:solidFill>
+              <a:ln/>
+            </p:spPr>
+            <p:txBody>
+              <a:bodyPr/>
+              <a:lstStyle/>
+              <a:p>
+                <a:endParaRPr lang="en-US"/>
+              </a:p>
+            </p:txBody>
+          </p:sp>
+          <p:sp>
+            <p:nvSpPr>
+              <p:cNvPr id="39" name="Text 32"/>
+              <p:cNvSpPr/>
+              <p:nvPr/>
+            </p:nvSpPr>
+            <p:spPr>
+              <a:xfrm>
+                <a:off x="12137351" y="5519022"/>
+                <a:ext cx="1633180" cy="217289"/>
+              </a:xfrm>
+              <a:prstGeom prst="rect">
+                <a:avLst/>
+              </a:prstGeom>
+              <a:noFill/>
+              <a:ln/>
+            </p:spPr>
+            <p:txBody>
+              <a:bodyPr wrap="none" lIns="0" tIns="0" rIns="0" bIns="0" rtlCol="0" anchor="t"/>
+              <a:lstStyle/>
+              <a:p>
+                <a:pPr marL="0" indent="0" algn="l">
+                  <a:lnSpc>
+                    <a:spcPts val="1700"/>
+                  </a:lnSpc>
+                  <a:buNone/>
+                </a:pPr>
+                <a:r>
+                  <a:rPr lang="en-US" sz="1300" dirty="0">
+                    <a:solidFill>
+                      <a:srgbClr val="272525"/>
+                    </a:solidFill>
+                    <a:latin typeface="Heebo" pitchFamily="34" charset="0"/>
+                    <a:ea typeface="Heebo" pitchFamily="34" charset="-122"/>
+                    <a:cs typeface="Heebo" pitchFamily="34" charset="-120"/>
+                  </a:rPr>
+                  <a:t>62 sq mi</a:t>
+                </a:r>
+                <a:endParaRPr lang="en-US" sz="1300" dirty="0"/>
+              </a:p>
+            </p:txBody>
+          </p:sp>
+          <p:sp>
+            <p:nvSpPr>
+              <p:cNvPr id="40" name="Shape 33"/>
+              <p:cNvSpPr/>
+              <p:nvPr/>
+            </p:nvSpPr>
+            <p:spPr>
+              <a:xfrm>
+                <a:off x="8179475" y="5792747"/>
+                <a:ext cx="5726906" cy="330160"/>
+              </a:xfrm>
+              <a:prstGeom prst="rect">
+                <a:avLst/>
+              </a:prstGeom>
+              <a:solidFill>
+                <a:srgbClr val="FFFFFF">
+                  <a:alpha val="4000"/>
+                </a:srgbClr>
+              </a:solidFill>
+              <a:ln/>
+            </p:spPr>
+            <p:txBody>
+              <a:bodyPr/>
+              <a:lstStyle/>
+              <a:p>
+                <a:endParaRPr lang="en-US"/>
+              </a:p>
+            </p:txBody>
+          </p:sp>
+          <p:sp>
+            <p:nvSpPr>
+              <p:cNvPr id="41" name="Shape 34"/>
+              <p:cNvSpPr/>
+              <p:nvPr/>
+            </p:nvSpPr>
+            <p:spPr>
+              <a:xfrm>
+                <a:off x="8180309" y="5792747"/>
+                <a:ext cx="1908691" cy="330160"/>
+              </a:xfrm>
+              <a:prstGeom prst="rect">
+                <a:avLst/>
+              </a:prstGeom>
+              <a:solidFill>
+                <a:srgbClr val="FAA1A1"/>
+              </a:solidFill>
+              <a:ln/>
+            </p:spPr>
+            <p:txBody>
+              <a:bodyPr/>
+              <a:lstStyle/>
+              <a:p>
+                <a:endParaRPr lang="en-US"/>
+              </a:p>
+            </p:txBody>
+          </p:sp>
+          <p:sp>
+            <p:nvSpPr>
+              <p:cNvPr id="42" name="Text 35"/>
+              <p:cNvSpPr/>
+              <p:nvPr/>
+            </p:nvSpPr>
+            <p:spPr>
+              <a:xfrm>
+                <a:off x="8316159" y="5849183"/>
+                <a:ext cx="1633180" cy="217289"/>
+              </a:xfrm>
+              <a:prstGeom prst="rect">
+                <a:avLst/>
+              </a:prstGeom>
+              <a:noFill/>
+              <a:ln/>
+            </p:spPr>
+            <p:txBody>
+              <a:bodyPr wrap="none" lIns="0" tIns="0" rIns="0" bIns="0" rtlCol="0" anchor="t"/>
+              <a:lstStyle/>
+              <a:p>
+                <a:pPr marL="0" indent="0" algn="l">
+                  <a:lnSpc>
+                    <a:spcPts val="1700"/>
+                  </a:lnSpc>
+                  <a:buNone/>
+                </a:pPr>
+                <a:r>
+                  <a:rPr lang="en-US" sz="1300" dirty="0">
+                    <a:solidFill>
+                      <a:srgbClr val="272525"/>
+                    </a:solidFill>
+                    <a:latin typeface="Heebo" pitchFamily="34" charset="0"/>
+                    <a:ea typeface="Heebo" pitchFamily="34" charset="-122"/>
+                    <a:cs typeface="Heebo" pitchFamily="34" charset="-120"/>
+                  </a:rPr>
+                  <a:t>38116</a:t>
+                </a:r>
+                <a:endParaRPr lang="en-US" sz="1300" dirty="0"/>
+              </a:p>
+            </p:txBody>
+          </p:sp>
+          <p:sp>
+            <p:nvSpPr>
+              <p:cNvPr id="43" name="Shape 36"/>
+              <p:cNvSpPr/>
+              <p:nvPr/>
+            </p:nvSpPr>
+            <p:spPr>
+              <a:xfrm>
+                <a:off x="10089000" y="5792747"/>
+                <a:ext cx="1908691" cy="330160"/>
+              </a:xfrm>
+              <a:prstGeom prst="rect">
+                <a:avLst/>
+              </a:prstGeom>
+              <a:solidFill>
+                <a:srgbClr val="FAA1A1"/>
+              </a:solidFill>
+              <a:ln/>
+            </p:spPr>
+            <p:txBody>
+              <a:bodyPr/>
+              <a:lstStyle/>
+              <a:p>
+                <a:endParaRPr lang="en-US"/>
+              </a:p>
+            </p:txBody>
+          </p:sp>
+          <p:sp>
+            <p:nvSpPr>
+              <p:cNvPr id="44" name="Text 37"/>
+              <p:cNvSpPr/>
+              <p:nvPr/>
+            </p:nvSpPr>
+            <p:spPr>
+              <a:xfrm>
+                <a:off x="10228660" y="5849183"/>
+                <a:ext cx="1629370" cy="217289"/>
+              </a:xfrm>
+              <a:prstGeom prst="rect">
+                <a:avLst/>
+              </a:prstGeom>
+              <a:noFill/>
+              <a:ln/>
+            </p:spPr>
+            <p:txBody>
+              <a:bodyPr wrap="none" lIns="0" tIns="0" rIns="0" bIns="0" rtlCol="0" anchor="t"/>
+              <a:lstStyle/>
+              <a:p>
+                <a:pPr marL="0" indent="0" algn="l">
+                  <a:lnSpc>
+                    <a:spcPts val="1700"/>
+                  </a:lnSpc>
+                  <a:buNone/>
+                </a:pPr>
+                <a:r>
+                  <a:rPr lang="en-US" sz="1300" dirty="0">
+                    <a:solidFill>
+                      <a:srgbClr val="272525"/>
+                    </a:solidFill>
+                    <a:latin typeface="Heebo" pitchFamily="34" charset="0"/>
+                    <a:ea typeface="Heebo" pitchFamily="34" charset="-122"/>
+                    <a:cs typeface="Heebo" pitchFamily="34" charset="-120"/>
+                  </a:rPr>
+                  <a:t>~40K</a:t>
+                </a:r>
+                <a:endParaRPr lang="en-US" sz="1300" dirty="0"/>
+              </a:p>
+            </p:txBody>
+          </p:sp>
+          <p:sp>
+            <p:nvSpPr>
+              <p:cNvPr id="45" name="Shape 38"/>
+              <p:cNvSpPr/>
+              <p:nvPr/>
+            </p:nvSpPr>
+            <p:spPr>
+              <a:xfrm>
+                <a:off x="11997691" y="5792747"/>
+                <a:ext cx="1908691" cy="330160"/>
+              </a:xfrm>
+              <a:prstGeom prst="rect">
+                <a:avLst/>
+              </a:prstGeom>
+              <a:solidFill>
+                <a:srgbClr val="FAA1A1"/>
+              </a:solidFill>
+              <a:ln/>
+            </p:spPr>
+            <p:txBody>
+              <a:bodyPr/>
+              <a:lstStyle/>
+              <a:p>
+                <a:endParaRPr lang="en-US"/>
+              </a:p>
+            </p:txBody>
+          </p:sp>
+          <p:sp>
+            <p:nvSpPr>
+              <p:cNvPr id="46" name="Text 39"/>
+              <p:cNvSpPr/>
+              <p:nvPr/>
+            </p:nvSpPr>
+            <p:spPr>
+              <a:xfrm>
+                <a:off x="12137351" y="5849183"/>
+                <a:ext cx="1633180" cy="217289"/>
+              </a:xfrm>
+              <a:prstGeom prst="rect">
+                <a:avLst/>
+              </a:prstGeom>
+              <a:noFill/>
+              <a:ln/>
+            </p:spPr>
+            <p:txBody>
+              <a:bodyPr wrap="none" lIns="0" tIns="0" rIns="0" bIns="0" rtlCol="0" anchor="t"/>
+              <a:lstStyle/>
+              <a:p>
+                <a:pPr marL="0" indent="0" algn="l">
+                  <a:lnSpc>
+                    <a:spcPts val="1700"/>
+                  </a:lnSpc>
+                  <a:buNone/>
+                </a:pPr>
+                <a:r>
+                  <a:rPr lang="en-US" sz="1300" dirty="0">
+                    <a:solidFill>
+                      <a:srgbClr val="272525"/>
+                    </a:solidFill>
+                    <a:latin typeface="Heebo" pitchFamily="34" charset="0"/>
+                    <a:ea typeface="Heebo" pitchFamily="34" charset="-122"/>
+                    <a:cs typeface="Heebo" pitchFamily="34" charset="-120"/>
+                  </a:rPr>
+                  <a:t>12 sq mi</a:t>
+                </a:r>
+                <a:endParaRPr lang="en-US" sz="1300" dirty="0"/>
+              </a:p>
+            </p:txBody>
+          </p:sp>
+          <p:sp>
+            <p:nvSpPr>
+              <p:cNvPr id="47" name="Shape 40"/>
+              <p:cNvSpPr/>
+              <p:nvPr/>
+            </p:nvSpPr>
+            <p:spPr>
+              <a:xfrm>
+                <a:off x="8179475" y="6122907"/>
+                <a:ext cx="5726906" cy="330160"/>
+              </a:xfrm>
+              <a:prstGeom prst="rect">
+                <a:avLst/>
+              </a:prstGeom>
+              <a:solidFill>
+                <a:srgbClr val="000000">
+                  <a:alpha val="4000"/>
+                </a:srgbClr>
+              </a:solidFill>
+              <a:ln/>
+            </p:spPr>
+            <p:txBody>
+              <a:bodyPr/>
+              <a:lstStyle/>
+              <a:p>
+                <a:endParaRPr lang="en-US"/>
+              </a:p>
+            </p:txBody>
+          </p:sp>
+          <p:sp>
+            <p:nvSpPr>
+              <p:cNvPr id="48" name="Shape 41"/>
+              <p:cNvSpPr/>
+              <p:nvPr/>
+            </p:nvSpPr>
+            <p:spPr>
+              <a:xfrm>
+                <a:off x="8180309" y="6122907"/>
+                <a:ext cx="1908691" cy="330160"/>
+              </a:xfrm>
+              <a:prstGeom prst="rect">
+                <a:avLst/>
+              </a:prstGeom>
+              <a:solidFill>
+                <a:srgbClr val="AEE4BD"/>
+              </a:solidFill>
+              <a:ln/>
+            </p:spPr>
+            <p:txBody>
+              <a:bodyPr/>
+              <a:lstStyle/>
+              <a:p>
+                <a:endParaRPr lang="en-US"/>
+              </a:p>
+            </p:txBody>
+          </p:sp>
+          <p:sp>
+            <p:nvSpPr>
+              <p:cNvPr id="49" name="Text 42"/>
+              <p:cNvSpPr/>
+              <p:nvPr/>
+            </p:nvSpPr>
+            <p:spPr>
+              <a:xfrm>
+                <a:off x="8316159" y="6179343"/>
+                <a:ext cx="1633180" cy="217289"/>
+              </a:xfrm>
+              <a:prstGeom prst="rect">
+                <a:avLst/>
+              </a:prstGeom>
+              <a:noFill/>
+              <a:ln/>
+            </p:spPr>
+            <p:txBody>
+              <a:bodyPr wrap="none" lIns="0" tIns="0" rIns="0" bIns="0" rtlCol="0" anchor="t"/>
+              <a:lstStyle/>
+              <a:p>
+                <a:pPr marL="0" indent="0" algn="l">
+                  <a:lnSpc>
+                    <a:spcPts val="1700"/>
+                  </a:lnSpc>
+                  <a:buNone/>
+                </a:pPr>
+                <a:r>
+                  <a:rPr lang="en-US" sz="1300" dirty="0">
+                    <a:solidFill>
+                      <a:srgbClr val="272525"/>
+                    </a:solidFill>
+                    <a:latin typeface="Heebo" pitchFamily="34" charset="0"/>
+                    <a:ea typeface="Heebo" pitchFamily="34" charset="-122"/>
+                    <a:cs typeface="Heebo" pitchFamily="34" charset="-120"/>
+                  </a:rPr>
+                  <a:t>38117</a:t>
+                </a:r>
+                <a:endParaRPr lang="en-US" sz="1300" dirty="0"/>
+              </a:p>
+            </p:txBody>
+          </p:sp>
+          <p:sp>
+            <p:nvSpPr>
+              <p:cNvPr id="50" name="Shape 43"/>
+              <p:cNvSpPr/>
+              <p:nvPr/>
+            </p:nvSpPr>
+            <p:spPr>
+              <a:xfrm>
+                <a:off x="10089000" y="6122907"/>
+                <a:ext cx="1908691" cy="330160"/>
+              </a:xfrm>
+              <a:prstGeom prst="rect">
+                <a:avLst/>
+              </a:prstGeom>
+              <a:solidFill>
+                <a:srgbClr val="AEE4BD"/>
+              </a:solidFill>
+              <a:ln/>
+            </p:spPr>
+            <p:txBody>
+              <a:bodyPr/>
+              <a:lstStyle/>
+              <a:p>
+                <a:endParaRPr lang="en-US"/>
+              </a:p>
+            </p:txBody>
+          </p:sp>
+          <p:sp>
+            <p:nvSpPr>
+              <p:cNvPr id="51" name="Text 44"/>
+              <p:cNvSpPr/>
+              <p:nvPr/>
+            </p:nvSpPr>
+            <p:spPr>
+              <a:xfrm>
+                <a:off x="10228660" y="6179343"/>
+                <a:ext cx="1629370" cy="217289"/>
+              </a:xfrm>
+              <a:prstGeom prst="rect">
+                <a:avLst/>
+              </a:prstGeom>
+              <a:noFill/>
+              <a:ln/>
+            </p:spPr>
+            <p:txBody>
+              <a:bodyPr wrap="none" lIns="0" tIns="0" rIns="0" bIns="0" rtlCol="0" anchor="t"/>
+              <a:lstStyle/>
+              <a:p>
+                <a:pPr marL="0" indent="0" algn="l">
+                  <a:lnSpc>
+                    <a:spcPts val="1700"/>
+                  </a:lnSpc>
+                  <a:buNone/>
+                </a:pPr>
+                <a:r>
+                  <a:rPr lang="en-US" sz="1300" dirty="0">
+                    <a:solidFill>
+                      <a:srgbClr val="272525"/>
+                    </a:solidFill>
+                    <a:latin typeface="Heebo" pitchFamily="34" charset="0"/>
+                    <a:ea typeface="Heebo" pitchFamily="34" charset="-122"/>
+                    <a:cs typeface="Heebo" pitchFamily="34" charset="-120"/>
+                  </a:rPr>
+                  <a:t>~26K</a:t>
+                </a:r>
+                <a:endParaRPr lang="en-US" sz="1300" dirty="0"/>
+              </a:p>
+            </p:txBody>
+          </p:sp>
+          <p:sp>
+            <p:nvSpPr>
+              <p:cNvPr id="52" name="Shape 45"/>
+              <p:cNvSpPr/>
+              <p:nvPr/>
+            </p:nvSpPr>
+            <p:spPr>
+              <a:xfrm>
+                <a:off x="11997691" y="6122907"/>
+                <a:ext cx="1908691" cy="330160"/>
+              </a:xfrm>
+              <a:prstGeom prst="rect">
+                <a:avLst/>
+              </a:prstGeom>
+              <a:solidFill>
+                <a:srgbClr val="AEE4BD"/>
+              </a:solidFill>
+              <a:ln/>
+            </p:spPr>
+            <p:txBody>
+              <a:bodyPr/>
+              <a:lstStyle/>
+              <a:p>
+                <a:endParaRPr lang="en-US"/>
+              </a:p>
+            </p:txBody>
+          </p:sp>
+          <p:sp>
+            <p:nvSpPr>
+              <p:cNvPr id="53" name="Text 46"/>
+              <p:cNvSpPr/>
+              <p:nvPr/>
+            </p:nvSpPr>
+            <p:spPr>
+              <a:xfrm>
+                <a:off x="12137351" y="6179343"/>
+                <a:ext cx="1633180" cy="217289"/>
+              </a:xfrm>
+              <a:prstGeom prst="rect">
+                <a:avLst/>
+              </a:prstGeom>
+              <a:noFill/>
+              <a:ln/>
+            </p:spPr>
+            <p:txBody>
+              <a:bodyPr wrap="none" lIns="0" tIns="0" rIns="0" bIns="0" rtlCol="0" anchor="t"/>
+              <a:lstStyle/>
+              <a:p>
+                <a:pPr marL="0" indent="0" algn="l">
+                  <a:lnSpc>
+                    <a:spcPts val="1700"/>
+                  </a:lnSpc>
+                  <a:buNone/>
+                </a:pPr>
+                <a:r>
+                  <a:rPr lang="en-US" sz="1300" dirty="0">
+                    <a:solidFill>
+                      <a:srgbClr val="272525"/>
+                    </a:solidFill>
+                    <a:latin typeface="Heebo" pitchFamily="34" charset="0"/>
+                    <a:ea typeface="Heebo" pitchFamily="34" charset="-122"/>
+                    <a:cs typeface="Heebo" pitchFamily="34" charset="-120"/>
+                  </a:rPr>
+                  <a:t>9 sq mi</a:t>
+                </a:r>
+                <a:endParaRPr lang="en-US" sz="1300" dirty="0"/>
+              </a:p>
+            </p:txBody>
+          </p:sp>
+        </p:grpSp>
+      </p:grpSp>
+      <p:sp>
+        <p:nvSpPr>
+          <p:cNvPr id="57" name="Text 49"/>
+          <p:cNvSpPr/>
+          <p:nvPr/>
+        </p:nvSpPr>
+        <p:spPr>
+          <a:xfrm>
+            <a:off x="731698" y="7979582"/>
+            <a:ext cx="13166884" cy="139065"/>
+          </a:xfrm>
+          <a:prstGeom prst="rect">
+            <a:avLst/>
+          </a:prstGeom>
+          <a:noFill/>
+          <a:ln/>
+        </p:spPr>
+        <p:txBody>
+          <a:bodyPr wrap="none" lIns="0" tIns="0" rIns="0" bIns="0" rtlCol="0" anchor="t"/>
+          <a:lstStyle/>
+          <a:p>
+            <a:pPr marL="0" indent="0" algn="l">
+              <a:lnSpc>
+                <a:spcPts val="1050"/>
+              </a:lnSpc>
+              <a:buNone/>
+            </a:pPr>
+            <a:r>
+              <a:rPr lang="en-US" sz="850" i="1" dirty="0">
+                <a:solidFill>
+                  <a:srgbClr val="4C4C4D"/>
+                </a:solidFill>
+                <a:latin typeface="Heebo" pitchFamily="34" charset="0"/>
+                <a:ea typeface="Heebo" pitchFamily="34" charset="-122"/>
+                <a:cs typeface="Heebo" pitchFamily="34" charset="-120"/>
+              </a:rPr>
+              <a:t>Source: IGS, ACS/Census, healthcare enrichment, uploaded analysis charts.</a:t>
+            </a:r>
+            <a:endParaRPr lang="en-US" sz="850" dirty="0"/>
           </a:p>
         </p:txBody>
       </p:sp>
       <p:pic>
         <p:nvPicPr>
-          <p:cNvPr id="5" name="Image 0" descr="preencoded.png"/>
-          <p:cNvPicPr>
-            <a:picLocks noChangeAspect="1"/>
-          </p:cNvPicPr>
-          <p:nvPr/>
-        </p:nvPicPr>
-        <p:blipFill>
-          <a:blip r:embed="rId3"/>
-          <a:stretch>
-            <a:fillRect/>
-          </a:stretch>
-        </p:blipFill>
-        <p:spPr>
-          <a:xfrm>
-            <a:off x="803315" y="1673781"/>
-            <a:ext cx="127992" cy="127992"/>
-          </a:xfrm>
-          <a:prstGeom prst="rect">
-            <a:avLst/>
-          </a:prstGeom>
-        </p:spPr>
-      </p:pic>
-      <p:sp>
-        <p:nvSpPr>
-          <p:cNvPr id="6" name="Text 3"/>
-          <p:cNvSpPr/>
-          <p:nvPr/>
-        </p:nvSpPr>
-        <p:spPr>
-          <a:xfrm>
-            <a:off x="973931" y="1654612"/>
-            <a:ext cx="1393627" cy="166330"/>
-          </a:xfrm>
-          <a:prstGeom prst="rect">
-            <a:avLst/>
-          </a:prstGeom>
-          <a:noFill/>
-          <a:ln/>
-        </p:spPr>
-        <p:txBody>
-          <a:bodyPr wrap="none" lIns="0" tIns="0" rIns="0" bIns="0" rtlCol="0" anchor="t"/>
-          <a:lstStyle/>
-          <a:p>
-            <a:pPr marL="0" indent="0" algn="l">
-              <a:lnSpc>
-                <a:spcPts val="1300"/>
-              </a:lnSpc>
-              <a:buNone/>
-            </a:pPr>
-            <a:r>
-              <a:rPr lang="en-US" sz="1000" dirty="0">
-                <a:solidFill>
-                  <a:srgbClr val="4C4C4D"/>
-                </a:solidFill>
-                <a:latin typeface="-apple-system, BlinkMacSystemFont, Segoe UI, Roboto, Helvetica Neue, Arial, sans-serif Medium" pitchFamily="34" charset="0"/>
-                <a:ea typeface="-apple-system, BlinkMacSystemFont, Segoe UI, Roboto, Helvetica Neue, Arial, sans-serif Medium" pitchFamily="34" charset="-122"/>
-                <a:cs typeface="-apple-system, BlinkMacSystemFont, Segoe UI, Roboto, Helvetica Neue, Arial, sans-serif Medium" pitchFamily="34" charset="-120"/>
-              </a:rPr>
-              <a:t>Our Shelby Community</a:t>
-            </a:r>
-            <a:endParaRPr lang="en-US" sz="1000" dirty="0"/>
-          </a:p>
-        </p:txBody>
-      </p:sp>
-      <p:sp>
-        <p:nvSpPr>
-          <p:cNvPr id="7" name="Shape 4"/>
-          <p:cNvSpPr/>
-          <p:nvPr/>
-        </p:nvSpPr>
-        <p:spPr>
-          <a:xfrm>
-            <a:off x="2500074" y="1625679"/>
-            <a:ext cx="1617226" cy="224195"/>
-          </a:xfrm>
-          <a:prstGeom prst="roundRect">
-            <a:avLst>
-              <a:gd name="adj" fmla="val 79940"/>
-            </a:avLst>
-          </a:prstGeom>
-          <a:solidFill>
-            <a:srgbClr val="FFFFFF">
-              <a:alpha val="20000"/>
-            </a:srgbClr>
-          </a:solidFill>
-          <a:ln w="7620">
-            <a:solidFill>
-              <a:srgbClr val="000000"/>
-            </a:solidFill>
-            <a:prstDash val="solid"/>
-          </a:ln>
-        </p:spPr>
-        <p:txBody>
-          <a:bodyPr/>
-          <a:lstStyle/>
-          <a:p>
-            <a:endParaRPr lang="en-US"/>
-          </a:p>
-        </p:txBody>
-      </p:sp>
-      <p:pic>
-        <p:nvPicPr>
-          <p:cNvPr id="8" name="Image 1" descr="preencoded.png"/>
-          <p:cNvPicPr>
-            <a:picLocks noChangeAspect="1"/>
-          </p:cNvPicPr>
-          <p:nvPr/>
-        </p:nvPicPr>
-        <p:blipFill>
-          <a:blip r:embed="rId4"/>
-          <a:stretch>
-            <a:fillRect/>
-          </a:stretch>
-        </p:blipFill>
-        <p:spPr>
-          <a:xfrm>
-            <a:off x="2571631" y="1673781"/>
-            <a:ext cx="127992" cy="127992"/>
-          </a:xfrm>
-          <a:prstGeom prst="rect">
-            <a:avLst/>
-          </a:prstGeom>
-        </p:spPr>
-      </p:pic>
-      <p:sp>
-        <p:nvSpPr>
-          <p:cNvPr id="9" name="Text 5"/>
-          <p:cNvSpPr/>
-          <p:nvPr/>
-        </p:nvSpPr>
-        <p:spPr>
-          <a:xfrm>
-            <a:off x="2742247" y="1654612"/>
-            <a:ext cx="1303496" cy="166330"/>
-          </a:xfrm>
-          <a:prstGeom prst="rect">
-            <a:avLst/>
-          </a:prstGeom>
-          <a:noFill/>
-          <a:ln/>
-        </p:spPr>
-        <p:txBody>
-          <a:bodyPr wrap="none" lIns="0" tIns="0" rIns="0" bIns="0" rtlCol="0" anchor="t"/>
-          <a:lstStyle/>
-          <a:p>
-            <a:pPr marL="0" indent="0" algn="l">
-              <a:lnSpc>
-                <a:spcPts val="1300"/>
-              </a:lnSpc>
-              <a:buNone/>
-            </a:pPr>
-            <a:r>
-              <a:rPr lang="en-US" sz="1000" dirty="0">
-                <a:solidFill>
-                  <a:srgbClr val="4C4C4D"/>
-                </a:solidFill>
-                <a:latin typeface="-apple-system, BlinkMacSystemFont, Segoe UI, Roboto, Helvetica Neue, Arial, sans-serif Medium" pitchFamily="34" charset="0"/>
-                <a:ea typeface="-apple-system, BlinkMacSystemFont, Segoe UI, Roboto, Helvetica Neue, Arial, sans-serif Medium" pitchFamily="34" charset="-122"/>
-                <a:cs typeface="-apple-system, BlinkMacSystemFont, Segoe UI, Roboto, Helvetica Neue, Arial, sans-serif Medium" pitchFamily="34" charset="-120"/>
-              </a:rPr>
-              <a:t>Rest of Shelby County</a:t>
-            </a:r>
-            <a:endParaRPr lang="en-US" sz="1000" dirty="0"/>
-          </a:p>
-        </p:txBody>
-      </p:sp>
-      <p:sp>
-        <p:nvSpPr>
-          <p:cNvPr id="10" name="Shape 6"/>
-          <p:cNvSpPr/>
-          <p:nvPr/>
-        </p:nvSpPr>
-        <p:spPr>
-          <a:xfrm>
-            <a:off x="4178260" y="1625679"/>
-            <a:ext cx="2246114" cy="224195"/>
-          </a:xfrm>
-          <a:prstGeom prst="roundRect">
-            <a:avLst>
-              <a:gd name="adj" fmla="val 79940"/>
-            </a:avLst>
-          </a:prstGeom>
-          <a:solidFill>
-            <a:srgbClr val="FFFFFF">
-              <a:alpha val="20000"/>
-            </a:srgbClr>
-          </a:solidFill>
-          <a:ln w="7620">
-            <a:solidFill>
-              <a:srgbClr val="000000"/>
-            </a:solidFill>
-            <a:prstDash val="solid"/>
-          </a:ln>
-        </p:spPr>
-        <p:txBody>
-          <a:bodyPr/>
-          <a:lstStyle/>
-          <a:p>
-            <a:endParaRPr lang="en-US"/>
-          </a:p>
-        </p:txBody>
-      </p:sp>
-      <p:pic>
-        <p:nvPicPr>
-          <p:cNvPr id="11" name="Image 2" descr="preencoded.png"/>
-          <p:cNvPicPr>
-            <a:picLocks noChangeAspect="1"/>
-          </p:cNvPicPr>
-          <p:nvPr/>
-        </p:nvPicPr>
-        <p:blipFill>
-          <a:blip r:embed="rId5"/>
-          <a:stretch>
-            <a:fillRect/>
-          </a:stretch>
-        </p:blipFill>
-        <p:spPr>
-          <a:xfrm>
-            <a:off x="4249817" y="1673781"/>
-            <a:ext cx="127992" cy="127992"/>
-          </a:xfrm>
-          <a:prstGeom prst="rect">
-            <a:avLst/>
-          </a:prstGeom>
-        </p:spPr>
-      </p:pic>
-      <p:sp>
-        <p:nvSpPr>
-          <p:cNvPr id="12" name="Text 7"/>
-          <p:cNvSpPr/>
-          <p:nvPr/>
-        </p:nvSpPr>
-        <p:spPr>
-          <a:xfrm>
-            <a:off x="4420433" y="1654612"/>
-            <a:ext cx="1932384" cy="166330"/>
-          </a:xfrm>
-          <a:prstGeom prst="rect">
-            <a:avLst/>
-          </a:prstGeom>
-          <a:noFill/>
-          <a:ln/>
-        </p:spPr>
-        <p:txBody>
-          <a:bodyPr wrap="none" lIns="0" tIns="0" rIns="0" bIns="0" rtlCol="0" anchor="t"/>
-          <a:lstStyle/>
-          <a:p>
-            <a:pPr marL="0" indent="0" algn="l">
-              <a:lnSpc>
-                <a:spcPts val="1300"/>
-              </a:lnSpc>
-              <a:buNone/>
-            </a:pPr>
-            <a:r>
-              <a:rPr lang="en-US" sz="1000" dirty="0">
-                <a:solidFill>
-                  <a:srgbClr val="4C4C4D"/>
-                </a:solidFill>
-                <a:latin typeface="-apple-system, BlinkMacSystemFont, Segoe UI, Roboto, Helvetica Neue, Arial, sans-serif Medium" pitchFamily="34" charset="0"/>
-                <a:ea typeface="-apple-system, BlinkMacSystemFont, Segoe UI, Roboto, Helvetica Neue, Arial, sans-serif Medium" pitchFamily="34" charset="-122"/>
-                <a:cs typeface="-apple-system, BlinkMacSystemFont, Segoe UI, Roboto, Helvetica Neue, Arial, sans-serif Medium" pitchFamily="34" charset="-120"/>
-              </a:rPr>
-              <a:t>High-Growth Shelby Community</a:t>
-            </a:r>
-            <a:endParaRPr lang="en-US" sz="1000" dirty="0"/>
-          </a:p>
-        </p:txBody>
-      </p:sp>
-      <p:pic>
-        <p:nvPicPr>
-          <p:cNvPr id="13" name="Image 3" descr="preencoded.png"/>
-          <p:cNvPicPr>
-            <a:picLocks noChangeAspect="1"/>
-          </p:cNvPicPr>
-          <p:nvPr/>
-        </p:nvPicPr>
-        <p:blipFill>
-          <a:blip r:embed="rId6"/>
-          <a:stretch>
-            <a:fillRect/>
-          </a:stretch>
-        </p:blipFill>
-        <p:spPr>
-          <a:xfrm>
-            <a:off x="731758" y="1956554"/>
-            <a:ext cx="6499979" cy="4879777"/>
-          </a:xfrm>
-          <a:prstGeom prst="rect">
-            <a:avLst/>
-          </a:prstGeom>
-        </p:spPr>
-      </p:pic>
-      <p:sp>
-        <p:nvSpPr>
-          <p:cNvPr id="14" name="Text 8"/>
-          <p:cNvSpPr/>
-          <p:nvPr/>
-        </p:nvSpPr>
-        <p:spPr>
-          <a:xfrm>
-            <a:off x="1111829" y="2341962"/>
-            <a:ext cx="179903" cy="178356"/>
-          </a:xfrm>
-          <a:prstGeom prst="rect">
-            <a:avLst/>
-          </a:prstGeom>
-          <a:noFill/>
-          <a:ln/>
-        </p:spPr>
-        <p:txBody>
-          <a:bodyPr wrap="none" lIns="30480" tIns="30480" rIns="30480" bIns="30480" rtlCol="0" anchor="t"/>
-          <a:lstStyle/>
-          <a:p>
-            <a:pPr marL="0" indent="0" algn="l">
-              <a:lnSpc>
-                <a:spcPts val="900"/>
-              </a:lnSpc>
-              <a:buNone/>
-            </a:pPr>
-            <a:r>
-              <a:rPr lang="en-US" sz="900" dirty="0">
-                <a:solidFill>
-                  <a:srgbClr val="000000"/>
-                </a:solidFill>
-                <a:latin typeface="-apple-system, BlinkMacSystemFont, Segoe UI, Roboto, Helvetica Neue, Arial, sans-serif Medium" pitchFamily="34" charset="0"/>
-                <a:ea typeface="-apple-system, BlinkMacSystemFont, Segoe UI, Roboto, Helvetica Neue, Arial, sans-serif Medium" pitchFamily="34" charset="-122"/>
-                <a:cs typeface="-apple-system, BlinkMacSystemFont, Segoe UI, Roboto, Helvetica Neue, Arial, sans-serif Medium" pitchFamily="34" charset="-120"/>
-              </a:rPr>
-              <a:t>77</a:t>
-            </a:r>
-            <a:endParaRPr lang="en-US" sz="900" dirty="0"/>
-          </a:p>
-        </p:txBody>
-      </p:sp>
-      <p:sp>
-        <p:nvSpPr>
-          <p:cNvPr id="15" name="Text 9"/>
-          <p:cNvSpPr/>
-          <p:nvPr/>
-        </p:nvSpPr>
-        <p:spPr>
-          <a:xfrm>
-            <a:off x="1508227" y="3340657"/>
-            <a:ext cx="179903" cy="178356"/>
-          </a:xfrm>
-          <a:prstGeom prst="rect">
-            <a:avLst/>
-          </a:prstGeom>
-          <a:noFill/>
-          <a:ln/>
-        </p:spPr>
-        <p:txBody>
-          <a:bodyPr wrap="none" lIns="30480" tIns="30480" rIns="30480" bIns="30480" rtlCol="0" anchor="t"/>
-          <a:lstStyle/>
-          <a:p>
-            <a:pPr marL="0" indent="0" algn="l">
-              <a:lnSpc>
-                <a:spcPts val="900"/>
-              </a:lnSpc>
-              <a:buNone/>
-            </a:pPr>
-            <a:r>
-              <a:rPr lang="en-US" sz="900" dirty="0">
-                <a:solidFill>
-                  <a:srgbClr val="000000"/>
-                </a:solidFill>
-                <a:latin typeface="-apple-system, BlinkMacSystemFont, Segoe UI, Roboto, Helvetica Neue, Arial, sans-serif Medium" pitchFamily="34" charset="0"/>
-                <a:ea typeface="-apple-system, BlinkMacSystemFont, Segoe UI, Roboto, Helvetica Neue, Arial, sans-serif Medium" pitchFamily="34" charset="-122"/>
-                <a:cs typeface="-apple-system, BlinkMacSystemFont, Segoe UI, Roboto, Helvetica Neue, Arial, sans-serif Medium" pitchFamily="34" charset="-120"/>
-              </a:rPr>
-              <a:t>58</a:t>
-            </a:r>
-            <a:endParaRPr lang="en-US" sz="900" dirty="0"/>
-          </a:p>
-        </p:txBody>
-      </p:sp>
-      <p:sp>
-        <p:nvSpPr>
-          <p:cNvPr id="16" name="Text 10"/>
-          <p:cNvSpPr/>
-          <p:nvPr/>
-        </p:nvSpPr>
-        <p:spPr>
-          <a:xfrm>
-            <a:off x="1904625" y="5075234"/>
-            <a:ext cx="179903" cy="178356"/>
-          </a:xfrm>
-          <a:prstGeom prst="rect">
-            <a:avLst/>
-          </a:prstGeom>
-          <a:noFill/>
-          <a:ln/>
-        </p:spPr>
-        <p:txBody>
-          <a:bodyPr wrap="none" lIns="30480" tIns="30480" rIns="30480" bIns="30480" rtlCol="0" anchor="t"/>
-          <a:lstStyle/>
-          <a:p>
-            <a:pPr marL="0" indent="0" algn="l">
-              <a:lnSpc>
-                <a:spcPts val="900"/>
-              </a:lnSpc>
-              <a:buNone/>
-            </a:pPr>
-            <a:r>
-              <a:rPr lang="en-US" sz="900" dirty="0">
-                <a:solidFill>
-                  <a:srgbClr val="000000"/>
-                </a:solidFill>
-                <a:latin typeface="-apple-system, BlinkMacSystemFont, Segoe UI, Roboto, Helvetica Neue, Arial, sans-serif Medium" pitchFamily="34" charset="0"/>
-                <a:ea typeface="-apple-system, BlinkMacSystemFont, Segoe UI, Roboto, Helvetica Neue, Arial, sans-serif Medium" pitchFamily="34" charset="-122"/>
-                <a:cs typeface="-apple-system, BlinkMacSystemFont, Segoe UI, Roboto, Helvetica Neue, Arial, sans-serif Medium" pitchFamily="34" charset="-120"/>
-              </a:rPr>
-              <a:t>25</a:t>
-            </a:r>
-            <a:endParaRPr lang="en-US" sz="900" dirty="0"/>
-          </a:p>
-        </p:txBody>
-      </p:sp>
-      <p:sp>
-        <p:nvSpPr>
-          <p:cNvPr id="17" name="Text 11"/>
-          <p:cNvSpPr/>
-          <p:nvPr/>
-        </p:nvSpPr>
-        <p:spPr>
-          <a:xfrm>
-            <a:off x="2661790" y="5548300"/>
-            <a:ext cx="179903" cy="178356"/>
-          </a:xfrm>
-          <a:prstGeom prst="rect">
-            <a:avLst/>
-          </a:prstGeom>
-          <a:noFill/>
-          <a:ln/>
-        </p:spPr>
-        <p:txBody>
-          <a:bodyPr wrap="none" lIns="30480" tIns="30480" rIns="30480" bIns="30480" rtlCol="0" anchor="t"/>
-          <a:lstStyle/>
-          <a:p>
-            <a:pPr marL="0" indent="0" algn="l">
-              <a:lnSpc>
-                <a:spcPts val="900"/>
-              </a:lnSpc>
-              <a:buNone/>
-            </a:pPr>
-            <a:r>
-              <a:rPr lang="en-US" sz="900" dirty="0">
-                <a:solidFill>
-                  <a:srgbClr val="000000"/>
-                </a:solidFill>
-                <a:latin typeface="-apple-system, BlinkMacSystemFont, Segoe UI, Roboto, Helvetica Neue, Arial, sans-serif Medium" pitchFamily="34" charset="0"/>
-                <a:ea typeface="-apple-system, BlinkMacSystemFont, Segoe UI, Roboto, Helvetica Neue, Arial, sans-serif Medium" pitchFamily="34" charset="-122"/>
-                <a:cs typeface="-apple-system, BlinkMacSystemFont, Segoe UI, Roboto, Helvetica Neue, Arial, sans-serif Medium" pitchFamily="34" charset="-120"/>
-              </a:rPr>
-              <a:t>16</a:t>
-            </a:r>
-            <a:endParaRPr lang="en-US" sz="900" dirty="0"/>
-          </a:p>
-        </p:txBody>
-      </p:sp>
-      <p:sp>
-        <p:nvSpPr>
-          <p:cNvPr id="18" name="Text 12"/>
-          <p:cNvSpPr/>
-          <p:nvPr/>
-        </p:nvSpPr>
-        <p:spPr>
-          <a:xfrm>
-            <a:off x="3058188" y="4970108"/>
-            <a:ext cx="179903" cy="178356"/>
-          </a:xfrm>
-          <a:prstGeom prst="rect">
-            <a:avLst/>
-          </a:prstGeom>
-          <a:noFill/>
-          <a:ln/>
-        </p:spPr>
-        <p:txBody>
-          <a:bodyPr wrap="none" lIns="30480" tIns="30480" rIns="30480" bIns="30480" rtlCol="0" anchor="t"/>
-          <a:lstStyle/>
-          <a:p>
-            <a:pPr marL="0" indent="0" algn="l">
-              <a:lnSpc>
-                <a:spcPts val="900"/>
-              </a:lnSpc>
-              <a:buNone/>
-            </a:pPr>
-            <a:r>
-              <a:rPr lang="en-US" sz="900" dirty="0">
-                <a:solidFill>
-                  <a:srgbClr val="000000"/>
-                </a:solidFill>
-                <a:latin typeface="-apple-system, BlinkMacSystemFont, Segoe UI, Roboto, Helvetica Neue, Arial, sans-serif Medium" pitchFamily="34" charset="0"/>
-                <a:ea typeface="-apple-system, BlinkMacSystemFont, Segoe UI, Roboto, Helvetica Neue, Arial, sans-serif Medium" pitchFamily="34" charset="-122"/>
-                <a:cs typeface="-apple-system, BlinkMacSystemFont, Segoe UI, Roboto, Helvetica Neue, Arial, sans-serif Medium" pitchFamily="34" charset="-120"/>
-              </a:rPr>
-              <a:t>27</a:t>
-            </a:r>
-            <a:endParaRPr lang="en-US" sz="900" dirty="0"/>
-          </a:p>
-        </p:txBody>
-      </p:sp>
-      <p:sp>
-        <p:nvSpPr>
-          <p:cNvPr id="19" name="Text 13"/>
-          <p:cNvSpPr/>
-          <p:nvPr/>
-        </p:nvSpPr>
-        <p:spPr>
-          <a:xfrm>
-            <a:off x="3454586" y="3077843"/>
-            <a:ext cx="179903" cy="178356"/>
-          </a:xfrm>
-          <a:prstGeom prst="rect">
-            <a:avLst/>
-          </a:prstGeom>
-          <a:noFill/>
-          <a:ln/>
-        </p:spPr>
-        <p:txBody>
-          <a:bodyPr wrap="none" lIns="30480" tIns="30480" rIns="30480" bIns="30480" rtlCol="0" anchor="t"/>
-          <a:lstStyle/>
-          <a:p>
-            <a:pPr marL="0" indent="0" algn="l">
-              <a:lnSpc>
-                <a:spcPts val="900"/>
-              </a:lnSpc>
-              <a:buNone/>
-            </a:pPr>
-            <a:r>
-              <a:rPr lang="en-US" sz="900" dirty="0">
-                <a:solidFill>
-                  <a:srgbClr val="000000"/>
-                </a:solidFill>
-                <a:latin typeface="-apple-system, BlinkMacSystemFont, Segoe UI, Roboto, Helvetica Neue, Arial, sans-serif Medium" pitchFamily="34" charset="0"/>
-                <a:ea typeface="-apple-system, BlinkMacSystemFont, Segoe UI, Roboto, Helvetica Neue, Arial, sans-serif Medium" pitchFamily="34" charset="-122"/>
-                <a:cs typeface="-apple-system, BlinkMacSystemFont, Segoe UI, Roboto, Helvetica Neue, Arial, sans-serif Medium" pitchFamily="34" charset="-120"/>
-              </a:rPr>
-              <a:t>63</a:t>
-            </a:r>
-            <a:endParaRPr lang="en-US" sz="900" dirty="0"/>
-          </a:p>
-        </p:txBody>
-      </p:sp>
-      <p:sp>
-        <p:nvSpPr>
-          <p:cNvPr id="20" name="Text 14"/>
-          <p:cNvSpPr/>
-          <p:nvPr/>
-        </p:nvSpPr>
-        <p:spPr>
-          <a:xfrm>
-            <a:off x="4245267" y="6097667"/>
-            <a:ext cx="112871" cy="178356"/>
-          </a:xfrm>
-          <a:prstGeom prst="rect">
-            <a:avLst/>
-          </a:prstGeom>
-          <a:noFill/>
-          <a:ln/>
-        </p:spPr>
-        <p:txBody>
-          <a:bodyPr wrap="none" lIns="30480" tIns="30480" rIns="30480" bIns="30480" rtlCol="0" anchor="t"/>
-          <a:lstStyle/>
-          <a:p>
-            <a:pPr marL="0" indent="0" algn="l">
-              <a:lnSpc>
-                <a:spcPts val="900"/>
-              </a:lnSpc>
-              <a:buNone/>
-            </a:pPr>
-            <a:r>
-              <a:rPr lang="en-US" sz="900" dirty="0">
-                <a:solidFill>
-                  <a:srgbClr val="000000"/>
-                </a:solidFill>
-                <a:latin typeface="-apple-system, BlinkMacSystemFont, Segoe UI, Roboto, Helvetica Neue, Arial, sans-serif Medium" pitchFamily="34" charset="0"/>
-                <a:ea typeface="-apple-system, BlinkMacSystemFont, Segoe UI, Roboto, Helvetica Neue, Arial, sans-serif Medium" pitchFamily="34" charset="-122"/>
-                <a:cs typeface="-apple-system, BlinkMacSystemFont, Segoe UI, Roboto, Helvetica Neue, Arial, sans-serif Medium" pitchFamily="34" charset="-120"/>
-              </a:rPr>
-              <a:t>1</a:t>
-            </a:r>
-            <a:endParaRPr lang="en-US" sz="900" dirty="0"/>
-          </a:p>
-        </p:txBody>
-      </p:sp>
-      <p:sp>
-        <p:nvSpPr>
-          <p:cNvPr id="21" name="Text 15"/>
-          <p:cNvSpPr/>
-          <p:nvPr/>
-        </p:nvSpPr>
-        <p:spPr>
-          <a:xfrm>
-            <a:off x="4641666" y="6045105"/>
-            <a:ext cx="112871" cy="178356"/>
-          </a:xfrm>
-          <a:prstGeom prst="rect">
-            <a:avLst/>
-          </a:prstGeom>
-          <a:noFill/>
-          <a:ln/>
-        </p:spPr>
-        <p:txBody>
-          <a:bodyPr wrap="none" lIns="30480" tIns="30480" rIns="30480" bIns="30480" rtlCol="0" anchor="t"/>
-          <a:lstStyle/>
-          <a:p>
-            <a:pPr marL="0" indent="0" algn="l">
-              <a:lnSpc>
-                <a:spcPts val="900"/>
-              </a:lnSpc>
-              <a:buNone/>
-            </a:pPr>
-            <a:r>
-              <a:rPr lang="en-US" sz="900" dirty="0">
-                <a:solidFill>
-                  <a:srgbClr val="000000"/>
-                </a:solidFill>
-                <a:latin typeface="-apple-system, BlinkMacSystemFont, Segoe UI, Roboto, Helvetica Neue, Arial, sans-serif Medium" pitchFamily="34" charset="0"/>
-                <a:ea typeface="-apple-system, BlinkMacSystemFont, Segoe UI, Roboto, Helvetica Neue, Arial, sans-serif Medium" pitchFamily="34" charset="-122"/>
-                <a:cs typeface="-apple-system, BlinkMacSystemFont, Segoe UI, Roboto, Helvetica Neue, Arial, sans-serif Medium" pitchFamily="34" charset="-120"/>
-              </a:rPr>
-              <a:t>2</a:t>
-            </a:r>
-            <a:endParaRPr lang="en-US" sz="900" dirty="0"/>
-          </a:p>
-        </p:txBody>
-      </p:sp>
-      <p:sp>
-        <p:nvSpPr>
-          <p:cNvPr id="22" name="Text 16"/>
-          <p:cNvSpPr/>
-          <p:nvPr/>
-        </p:nvSpPr>
-        <p:spPr>
-          <a:xfrm>
-            <a:off x="5038064" y="6073930"/>
-            <a:ext cx="112871" cy="178356"/>
-          </a:xfrm>
-          <a:prstGeom prst="rect">
-            <a:avLst/>
-          </a:prstGeom>
-          <a:noFill/>
-          <a:ln/>
-        </p:spPr>
-        <p:txBody>
-          <a:bodyPr wrap="none" lIns="30480" tIns="30480" rIns="30480" bIns="30480" rtlCol="0" anchor="t"/>
-          <a:lstStyle/>
-          <a:p>
-            <a:pPr marL="0" indent="0" algn="l">
-              <a:lnSpc>
-                <a:spcPts val="900"/>
-              </a:lnSpc>
-              <a:buNone/>
-            </a:pPr>
-            <a:r>
-              <a:rPr lang="en-US" sz="900" dirty="0">
-                <a:solidFill>
-                  <a:srgbClr val="000000"/>
-                </a:solidFill>
-                <a:latin typeface="-apple-system, BlinkMacSystemFont, Segoe UI, Roboto, Helvetica Neue, Arial, sans-serif Medium" pitchFamily="34" charset="0"/>
-                <a:ea typeface="-apple-system, BlinkMacSystemFont, Segoe UI, Roboto, Helvetica Neue, Arial, sans-serif Medium" pitchFamily="34" charset="-122"/>
-                <a:cs typeface="-apple-system, BlinkMacSystemFont, Segoe UI, Roboto, Helvetica Neue, Arial, sans-serif Medium" pitchFamily="34" charset="-120"/>
-              </a:rPr>
-              <a:t>6</a:t>
-            </a:r>
-            <a:endParaRPr lang="en-US" sz="900" dirty="0"/>
-          </a:p>
-        </p:txBody>
-      </p:sp>
-      <p:sp>
-        <p:nvSpPr>
-          <p:cNvPr id="23" name="Text 17"/>
-          <p:cNvSpPr/>
-          <p:nvPr/>
-        </p:nvSpPr>
-        <p:spPr>
-          <a:xfrm>
-            <a:off x="5795229" y="6021367"/>
-            <a:ext cx="112871" cy="178356"/>
-          </a:xfrm>
-          <a:prstGeom prst="rect">
-            <a:avLst/>
-          </a:prstGeom>
-          <a:noFill/>
-          <a:ln/>
-        </p:spPr>
-        <p:txBody>
-          <a:bodyPr wrap="none" lIns="30480" tIns="30480" rIns="30480" bIns="30480" rtlCol="0" anchor="t"/>
-          <a:lstStyle/>
-          <a:p>
-            <a:pPr marL="0" indent="0" algn="l">
-              <a:lnSpc>
-                <a:spcPts val="900"/>
-              </a:lnSpc>
-              <a:buNone/>
-            </a:pPr>
-            <a:r>
-              <a:rPr lang="en-US" sz="900" dirty="0">
-                <a:solidFill>
-                  <a:srgbClr val="000000"/>
-                </a:solidFill>
-                <a:latin typeface="-apple-system, BlinkMacSystemFont, Segoe UI, Roboto, Helvetica Neue, Arial, sans-serif Medium" pitchFamily="34" charset="0"/>
-                <a:ea typeface="-apple-system, BlinkMacSystemFont, Segoe UI, Roboto, Helvetica Neue, Arial, sans-serif Medium" pitchFamily="34" charset="-122"/>
-                <a:cs typeface="-apple-system, BlinkMacSystemFont, Segoe UI, Roboto, Helvetica Neue, Arial, sans-serif Medium" pitchFamily="34" charset="-120"/>
-              </a:rPr>
-              <a:t>7</a:t>
-            </a:r>
-            <a:endParaRPr lang="en-US" sz="900" dirty="0"/>
-          </a:p>
-        </p:txBody>
-      </p:sp>
-      <p:sp>
-        <p:nvSpPr>
-          <p:cNvPr id="24" name="Text 18"/>
-          <p:cNvSpPr/>
-          <p:nvPr/>
-        </p:nvSpPr>
-        <p:spPr>
-          <a:xfrm>
-            <a:off x="6158111" y="5705989"/>
-            <a:ext cx="179903" cy="178356"/>
-          </a:xfrm>
-          <a:prstGeom prst="rect">
-            <a:avLst/>
-          </a:prstGeom>
-          <a:noFill/>
-          <a:ln/>
-        </p:spPr>
-        <p:txBody>
-          <a:bodyPr wrap="none" lIns="30480" tIns="30480" rIns="30480" bIns="30480" rtlCol="0" anchor="t"/>
-          <a:lstStyle/>
-          <a:p>
-            <a:pPr marL="0" indent="0" algn="l">
-              <a:lnSpc>
-                <a:spcPts val="900"/>
-              </a:lnSpc>
-              <a:buNone/>
-            </a:pPr>
-            <a:r>
-              <a:rPr lang="en-US" sz="900" dirty="0">
-                <a:solidFill>
-                  <a:srgbClr val="000000"/>
-                </a:solidFill>
-                <a:latin typeface="-apple-system, BlinkMacSystemFont, Segoe UI, Roboto, Helvetica Neue, Arial, sans-serif Medium" pitchFamily="34" charset="0"/>
-                <a:ea typeface="-apple-system, BlinkMacSystemFont, Segoe UI, Roboto, Helvetica Neue, Arial, sans-serif Medium" pitchFamily="34" charset="-122"/>
-                <a:cs typeface="-apple-system, BlinkMacSystemFont, Segoe UI, Roboto, Helvetica Neue, Arial, sans-serif Medium" pitchFamily="34" charset="-120"/>
-              </a:rPr>
-              <a:t>13</a:t>
-            </a:r>
-            <a:endParaRPr lang="en-US" sz="900" dirty="0"/>
-          </a:p>
-        </p:txBody>
-      </p:sp>
-      <p:sp>
-        <p:nvSpPr>
-          <p:cNvPr id="25" name="Text 19"/>
-          <p:cNvSpPr/>
-          <p:nvPr/>
-        </p:nvSpPr>
-        <p:spPr>
-          <a:xfrm>
-            <a:off x="6588025" y="6073930"/>
-            <a:ext cx="112871" cy="178356"/>
-          </a:xfrm>
-          <a:prstGeom prst="rect">
-            <a:avLst/>
-          </a:prstGeom>
-          <a:noFill/>
-          <a:ln/>
-        </p:spPr>
-        <p:txBody>
-          <a:bodyPr wrap="none" lIns="30480" tIns="30480" rIns="30480" bIns="30480" rtlCol="0" anchor="t"/>
-          <a:lstStyle/>
-          <a:p>
-            <a:pPr marL="0" indent="0" algn="l">
-              <a:lnSpc>
-                <a:spcPts val="900"/>
-              </a:lnSpc>
-              <a:buNone/>
-            </a:pPr>
-            <a:r>
-              <a:rPr lang="en-US" sz="900" dirty="0">
-                <a:solidFill>
-                  <a:srgbClr val="000000"/>
-                </a:solidFill>
-                <a:latin typeface="-apple-system, BlinkMacSystemFont, Segoe UI, Roboto, Helvetica Neue, Arial, sans-serif Medium" pitchFamily="34" charset="0"/>
-                <a:ea typeface="-apple-system, BlinkMacSystemFont, Segoe UI, Roboto, Helvetica Neue, Arial, sans-serif Medium" pitchFamily="34" charset="-122"/>
-                <a:cs typeface="-apple-system, BlinkMacSystemFont, Segoe UI, Roboto, Helvetica Neue, Arial, sans-serif Medium" pitchFamily="34" charset="-120"/>
-              </a:rPr>
-              <a:t>6</a:t>
-            </a:r>
-            <a:endParaRPr lang="en-US" sz="900" dirty="0"/>
-          </a:p>
-        </p:txBody>
-      </p:sp>
-      <p:pic>
-        <p:nvPicPr>
-          <p:cNvPr id="26" name="Image 4" descr="preencoded.png"/>
+          <p:cNvPr id="70" name="Picture 69">
+            <a:extLst>
+              <a:ext uri="{FF2B5EF4-FFF2-40B4-BE49-F238E27FC236}">
+                <a16:creationId xmlns:a16="http://schemas.microsoft.com/office/drawing/2014/main" id="{78AD2143-231A-F349-DD82-E9A882A387E2}"/>
+              </a:ext>
+            </a:extLst>
+          </p:cNvPr>
           <p:cNvPicPr>
             <a:picLocks noChangeAspect="1"/>
           </p:cNvPicPr>
@@ -5527,1101 +6710,14 @@
         </p:blipFill>
         <p:spPr>
           <a:xfrm>
-            <a:off x="8466064" y="1822344"/>
-            <a:ext cx="5153727" cy="2867710"/>
+            <a:off x="7674028" y="1737840"/>
+            <a:ext cx="6243442" cy="3862699"/>
           </a:xfrm>
           <a:prstGeom prst="rect">
             <a:avLst/>
           </a:prstGeom>
         </p:spPr>
       </p:pic>
-      <p:sp>
-        <p:nvSpPr>
-          <p:cNvPr id="27" name="Text 20"/>
-          <p:cNvSpPr/>
-          <p:nvPr/>
-        </p:nvSpPr>
-        <p:spPr>
-          <a:xfrm>
-            <a:off x="8171855" y="4820959"/>
-            <a:ext cx="1805821" cy="212288"/>
-          </a:xfrm>
-          <a:prstGeom prst="rect">
-            <a:avLst/>
-          </a:prstGeom>
-          <a:noFill/>
-          <a:ln/>
-        </p:spPr>
-        <p:txBody>
-          <a:bodyPr wrap="none" lIns="0" tIns="0" rIns="0" bIns="0" rtlCol="0" anchor="t"/>
-          <a:lstStyle/>
-          <a:p>
-            <a:pPr marL="0" indent="0" algn="l">
-              <a:lnSpc>
-                <a:spcPts val="1650"/>
-              </a:lnSpc>
-              <a:buNone/>
-            </a:pPr>
-            <a:r>
-              <a:rPr lang="en-US" sz="1300" dirty="0">
-                <a:solidFill>
-                  <a:srgbClr val="152D47"/>
-                </a:solidFill>
-                <a:latin typeface="Crimson Pro Semi Bold" pitchFamily="34" charset="0"/>
-                <a:ea typeface="Crimson Pro Semi Bold" pitchFamily="34" charset="-122"/>
-                <a:cs typeface="Crimson Pro Semi Bold" pitchFamily="34" charset="-120"/>
-              </a:rPr>
-              <a:t>Whitehaven ZIPs of Focus</a:t>
-            </a:r>
-            <a:endParaRPr lang="en-US" sz="1300" dirty="0"/>
-          </a:p>
-        </p:txBody>
-      </p:sp>
-      <p:sp>
-        <p:nvSpPr>
-          <p:cNvPr id="28" name="Shape 21"/>
-          <p:cNvSpPr/>
-          <p:nvPr/>
-        </p:nvSpPr>
-        <p:spPr>
-          <a:xfrm>
-            <a:off x="8171855" y="5124807"/>
-            <a:ext cx="5742742" cy="1335881"/>
-          </a:xfrm>
-          <a:prstGeom prst="roundRect">
-            <a:avLst>
-              <a:gd name="adj" fmla="val 1526"/>
-            </a:avLst>
-          </a:prstGeom>
-          <a:noFill/>
-          <a:ln w="7620">
-            <a:solidFill>
-              <a:srgbClr val="000000">
-                <a:alpha val="8000"/>
-              </a:srgbClr>
-            </a:solidFill>
-            <a:prstDash val="solid"/>
-          </a:ln>
-        </p:spPr>
-        <p:txBody>
-          <a:bodyPr/>
-          <a:lstStyle/>
-          <a:p>
-            <a:endParaRPr lang="en-US"/>
-          </a:p>
-        </p:txBody>
-      </p:sp>
-      <p:sp>
-        <p:nvSpPr>
-          <p:cNvPr id="29" name="Shape 22"/>
-          <p:cNvSpPr/>
-          <p:nvPr/>
-        </p:nvSpPr>
-        <p:spPr>
-          <a:xfrm>
-            <a:off x="8179475" y="5132427"/>
-            <a:ext cx="5726906" cy="330160"/>
-          </a:xfrm>
-          <a:prstGeom prst="rect">
-            <a:avLst/>
-          </a:prstGeom>
-          <a:solidFill>
-            <a:srgbClr val="FFFFFF">
-              <a:alpha val="4000"/>
-            </a:srgbClr>
-          </a:solidFill>
-          <a:ln/>
-        </p:spPr>
-        <p:txBody>
-          <a:bodyPr/>
-          <a:lstStyle/>
-          <a:p>
-            <a:endParaRPr lang="en-US"/>
-          </a:p>
-        </p:txBody>
-      </p:sp>
-      <p:sp>
-        <p:nvSpPr>
-          <p:cNvPr id="30" name="Text 23"/>
-          <p:cNvSpPr/>
-          <p:nvPr/>
-        </p:nvSpPr>
-        <p:spPr>
-          <a:xfrm>
-            <a:off x="8316159" y="5188862"/>
-            <a:ext cx="1633180" cy="217289"/>
-          </a:xfrm>
-          <a:prstGeom prst="rect">
-            <a:avLst/>
-          </a:prstGeom>
-          <a:noFill/>
-          <a:ln/>
-        </p:spPr>
-        <p:txBody>
-          <a:bodyPr wrap="none" lIns="0" tIns="0" rIns="0" bIns="0" rtlCol="0" anchor="t"/>
-          <a:lstStyle/>
-          <a:p>
-            <a:pPr marL="0" indent="0" algn="l">
-              <a:lnSpc>
-                <a:spcPts val="1700"/>
-              </a:lnSpc>
-              <a:buNone/>
-            </a:pPr>
-            <a:r>
-              <a:rPr lang="en-US" sz="1300" b="1" dirty="0">
-                <a:solidFill>
-                  <a:srgbClr val="4C4C4D"/>
-                </a:solidFill>
-                <a:latin typeface="Heebo" pitchFamily="34" charset="0"/>
-                <a:ea typeface="Heebo" pitchFamily="34" charset="-122"/>
-                <a:cs typeface="Heebo" pitchFamily="34" charset="-120"/>
-              </a:rPr>
-              <a:t>ZIP</a:t>
-            </a:r>
-            <a:endParaRPr lang="en-US" sz="1300" dirty="0"/>
-          </a:p>
-        </p:txBody>
-      </p:sp>
-      <p:sp>
-        <p:nvSpPr>
-          <p:cNvPr id="31" name="Text 24"/>
-          <p:cNvSpPr/>
-          <p:nvPr/>
-        </p:nvSpPr>
-        <p:spPr>
-          <a:xfrm>
-            <a:off x="10228660" y="5188862"/>
-            <a:ext cx="1629370" cy="217289"/>
-          </a:xfrm>
-          <a:prstGeom prst="rect">
-            <a:avLst/>
-          </a:prstGeom>
-          <a:noFill/>
-          <a:ln/>
-        </p:spPr>
-        <p:txBody>
-          <a:bodyPr wrap="none" lIns="0" tIns="0" rIns="0" bIns="0" rtlCol="0" anchor="t"/>
-          <a:lstStyle/>
-          <a:p>
-            <a:pPr marL="0" indent="0" algn="l">
-              <a:lnSpc>
-                <a:spcPts val="1700"/>
-              </a:lnSpc>
-              <a:buNone/>
-            </a:pPr>
-            <a:r>
-              <a:rPr lang="en-US" sz="1300" b="1" dirty="0">
-                <a:solidFill>
-                  <a:srgbClr val="4C4C4D"/>
-                </a:solidFill>
-                <a:latin typeface="Heebo" pitchFamily="34" charset="0"/>
-                <a:ea typeface="Heebo" pitchFamily="34" charset="-122"/>
-                <a:cs typeface="Heebo" pitchFamily="34" charset="-120"/>
-              </a:rPr>
-              <a:t>Population</a:t>
-            </a:r>
-            <a:endParaRPr lang="en-US" sz="1300" dirty="0"/>
-          </a:p>
-        </p:txBody>
-      </p:sp>
-      <p:sp>
-        <p:nvSpPr>
-          <p:cNvPr id="32" name="Text 25"/>
-          <p:cNvSpPr/>
-          <p:nvPr/>
-        </p:nvSpPr>
-        <p:spPr>
-          <a:xfrm>
-            <a:off x="12137351" y="5188862"/>
-            <a:ext cx="1633180" cy="217289"/>
-          </a:xfrm>
-          <a:prstGeom prst="rect">
-            <a:avLst/>
-          </a:prstGeom>
-          <a:noFill/>
-          <a:ln/>
-        </p:spPr>
-        <p:txBody>
-          <a:bodyPr wrap="none" lIns="0" tIns="0" rIns="0" bIns="0" rtlCol="0" anchor="t"/>
-          <a:lstStyle/>
-          <a:p>
-            <a:pPr marL="0" indent="0" algn="l">
-              <a:lnSpc>
-                <a:spcPts val="1700"/>
-              </a:lnSpc>
-              <a:buNone/>
-            </a:pPr>
-            <a:r>
-              <a:rPr lang="en-US" sz="1300" b="1" dirty="0">
-                <a:solidFill>
-                  <a:srgbClr val="4C4C4D"/>
-                </a:solidFill>
-                <a:latin typeface="Heebo" pitchFamily="34" charset="0"/>
-                <a:ea typeface="Heebo" pitchFamily="34" charset="-122"/>
-                <a:cs typeface="Heebo" pitchFamily="34" charset="-120"/>
-              </a:rPr>
-              <a:t>Area</a:t>
-            </a:r>
-            <a:endParaRPr lang="en-US" sz="1300" dirty="0"/>
-          </a:p>
-        </p:txBody>
-      </p:sp>
-      <p:sp>
-        <p:nvSpPr>
-          <p:cNvPr id="33" name="Shape 26"/>
-          <p:cNvSpPr/>
-          <p:nvPr/>
-        </p:nvSpPr>
-        <p:spPr>
-          <a:xfrm>
-            <a:off x="8179475" y="5462587"/>
-            <a:ext cx="5726906" cy="330160"/>
-          </a:xfrm>
-          <a:prstGeom prst="rect">
-            <a:avLst/>
-          </a:prstGeom>
-          <a:solidFill>
-            <a:srgbClr val="000000">
-              <a:alpha val="4000"/>
-            </a:srgbClr>
-          </a:solidFill>
-          <a:ln/>
-        </p:spPr>
-        <p:txBody>
-          <a:bodyPr/>
-          <a:lstStyle/>
-          <a:p>
-            <a:endParaRPr lang="en-US"/>
-          </a:p>
-        </p:txBody>
-      </p:sp>
-      <p:sp>
-        <p:nvSpPr>
-          <p:cNvPr id="34" name="Shape 27"/>
-          <p:cNvSpPr/>
-          <p:nvPr/>
-        </p:nvSpPr>
-        <p:spPr>
-          <a:xfrm>
-            <a:off x="8180309" y="5462587"/>
-            <a:ext cx="1908691" cy="330160"/>
-          </a:xfrm>
-          <a:prstGeom prst="rect">
-            <a:avLst/>
-          </a:prstGeom>
-          <a:solidFill>
-            <a:srgbClr val="FAA1A1"/>
-          </a:solidFill>
-          <a:ln/>
-        </p:spPr>
-        <p:txBody>
-          <a:bodyPr/>
-          <a:lstStyle/>
-          <a:p>
-            <a:endParaRPr lang="en-US"/>
-          </a:p>
-        </p:txBody>
-      </p:sp>
-      <p:sp>
-        <p:nvSpPr>
-          <p:cNvPr id="35" name="Text 28"/>
-          <p:cNvSpPr/>
-          <p:nvPr/>
-        </p:nvSpPr>
-        <p:spPr>
-          <a:xfrm>
-            <a:off x="8316159" y="5519022"/>
-            <a:ext cx="1633180" cy="217289"/>
-          </a:xfrm>
-          <a:prstGeom prst="rect">
-            <a:avLst/>
-          </a:prstGeom>
-          <a:noFill/>
-          <a:ln/>
-        </p:spPr>
-        <p:txBody>
-          <a:bodyPr wrap="none" lIns="0" tIns="0" rIns="0" bIns="0" rtlCol="0" anchor="t"/>
-          <a:lstStyle/>
-          <a:p>
-            <a:pPr marL="0" indent="0" algn="l">
-              <a:lnSpc>
-                <a:spcPts val="1700"/>
-              </a:lnSpc>
-              <a:buNone/>
-            </a:pPr>
-            <a:r>
-              <a:rPr lang="en-US" sz="1300" dirty="0">
-                <a:solidFill>
-                  <a:srgbClr val="272525"/>
-                </a:solidFill>
-                <a:latin typeface="Heebo" pitchFamily="34" charset="0"/>
-                <a:ea typeface="Heebo" pitchFamily="34" charset="-122"/>
-                <a:cs typeface="Heebo" pitchFamily="34" charset="-120"/>
-              </a:rPr>
-              <a:t>38109</a:t>
-            </a:r>
-            <a:endParaRPr lang="en-US" sz="1300" dirty="0"/>
-          </a:p>
-        </p:txBody>
-      </p:sp>
-      <p:sp>
-        <p:nvSpPr>
-          <p:cNvPr id="36" name="Shape 29"/>
-          <p:cNvSpPr/>
-          <p:nvPr/>
-        </p:nvSpPr>
-        <p:spPr>
-          <a:xfrm>
-            <a:off x="10089000" y="5462587"/>
-            <a:ext cx="1908691" cy="330160"/>
-          </a:xfrm>
-          <a:prstGeom prst="rect">
-            <a:avLst/>
-          </a:prstGeom>
-          <a:solidFill>
-            <a:srgbClr val="FAA1A1"/>
-          </a:solidFill>
-          <a:ln/>
-        </p:spPr>
-        <p:txBody>
-          <a:bodyPr/>
-          <a:lstStyle/>
-          <a:p>
-            <a:endParaRPr lang="en-US"/>
-          </a:p>
-        </p:txBody>
-      </p:sp>
-      <p:sp>
-        <p:nvSpPr>
-          <p:cNvPr id="37" name="Text 30"/>
-          <p:cNvSpPr/>
-          <p:nvPr/>
-        </p:nvSpPr>
-        <p:spPr>
-          <a:xfrm>
-            <a:off x="10228660" y="5519022"/>
-            <a:ext cx="1629370" cy="217289"/>
-          </a:xfrm>
-          <a:prstGeom prst="rect">
-            <a:avLst/>
-          </a:prstGeom>
-          <a:noFill/>
-          <a:ln/>
-        </p:spPr>
-        <p:txBody>
-          <a:bodyPr wrap="none" lIns="0" tIns="0" rIns="0" bIns="0" rtlCol="0" anchor="t"/>
-          <a:lstStyle/>
-          <a:p>
-            <a:pPr marL="0" indent="0" algn="l">
-              <a:lnSpc>
-                <a:spcPts val="1700"/>
-              </a:lnSpc>
-              <a:buNone/>
-            </a:pPr>
-            <a:r>
-              <a:rPr lang="en-US" sz="1300" dirty="0">
-                <a:solidFill>
-                  <a:srgbClr val="272525"/>
-                </a:solidFill>
-                <a:latin typeface="Heebo" pitchFamily="34" charset="0"/>
-                <a:ea typeface="Heebo" pitchFamily="34" charset="-122"/>
-                <a:cs typeface="Heebo" pitchFamily="34" charset="-120"/>
-              </a:rPr>
-              <a:t>~50K</a:t>
-            </a:r>
-            <a:endParaRPr lang="en-US" sz="1300" dirty="0"/>
-          </a:p>
-        </p:txBody>
-      </p:sp>
-      <p:sp>
-        <p:nvSpPr>
-          <p:cNvPr id="38" name="Shape 31"/>
-          <p:cNvSpPr/>
-          <p:nvPr/>
-        </p:nvSpPr>
-        <p:spPr>
-          <a:xfrm>
-            <a:off x="11997691" y="5462587"/>
-            <a:ext cx="1908691" cy="330160"/>
-          </a:xfrm>
-          <a:prstGeom prst="rect">
-            <a:avLst/>
-          </a:prstGeom>
-          <a:solidFill>
-            <a:srgbClr val="FAA1A1"/>
-          </a:solidFill>
-          <a:ln/>
-        </p:spPr>
-        <p:txBody>
-          <a:bodyPr/>
-          <a:lstStyle/>
-          <a:p>
-            <a:endParaRPr lang="en-US"/>
-          </a:p>
-        </p:txBody>
-      </p:sp>
-      <p:sp>
-        <p:nvSpPr>
-          <p:cNvPr id="39" name="Text 32"/>
-          <p:cNvSpPr/>
-          <p:nvPr/>
-        </p:nvSpPr>
-        <p:spPr>
-          <a:xfrm>
-            <a:off x="12137351" y="5519022"/>
-            <a:ext cx="1633180" cy="217289"/>
-          </a:xfrm>
-          <a:prstGeom prst="rect">
-            <a:avLst/>
-          </a:prstGeom>
-          <a:noFill/>
-          <a:ln/>
-        </p:spPr>
-        <p:txBody>
-          <a:bodyPr wrap="none" lIns="0" tIns="0" rIns="0" bIns="0" rtlCol="0" anchor="t"/>
-          <a:lstStyle/>
-          <a:p>
-            <a:pPr marL="0" indent="0" algn="l">
-              <a:lnSpc>
-                <a:spcPts val="1700"/>
-              </a:lnSpc>
-              <a:buNone/>
-            </a:pPr>
-            <a:r>
-              <a:rPr lang="en-US" sz="1300" dirty="0">
-                <a:solidFill>
-                  <a:srgbClr val="272525"/>
-                </a:solidFill>
-                <a:latin typeface="Heebo" pitchFamily="34" charset="0"/>
-                <a:ea typeface="Heebo" pitchFamily="34" charset="-122"/>
-                <a:cs typeface="Heebo" pitchFamily="34" charset="-120"/>
-              </a:rPr>
-              <a:t>62 sq mi</a:t>
-            </a:r>
-            <a:endParaRPr lang="en-US" sz="1300" dirty="0"/>
-          </a:p>
-        </p:txBody>
-      </p:sp>
-      <p:sp>
-        <p:nvSpPr>
-          <p:cNvPr id="40" name="Shape 33"/>
-          <p:cNvSpPr/>
-          <p:nvPr/>
-        </p:nvSpPr>
-        <p:spPr>
-          <a:xfrm>
-            <a:off x="8179475" y="5792747"/>
-            <a:ext cx="5726906" cy="330160"/>
-          </a:xfrm>
-          <a:prstGeom prst="rect">
-            <a:avLst/>
-          </a:prstGeom>
-          <a:solidFill>
-            <a:srgbClr val="FFFFFF">
-              <a:alpha val="4000"/>
-            </a:srgbClr>
-          </a:solidFill>
-          <a:ln/>
-        </p:spPr>
-        <p:txBody>
-          <a:bodyPr/>
-          <a:lstStyle/>
-          <a:p>
-            <a:endParaRPr lang="en-US"/>
-          </a:p>
-        </p:txBody>
-      </p:sp>
-      <p:sp>
-        <p:nvSpPr>
-          <p:cNvPr id="41" name="Shape 34"/>
-          <p:cNvSpPr/>
-          <p:nvPr/>
-        </p:nvSpPr>
-        <p:spPr>
-          <a:xfrm>
-            <a:off x="8180309" y="5792747"/>
-            <a:ext cx="1908691" cy="330160"/>
-          </a:xfrm>
-          <a:prstGeom prst="rect">
-            <a:avLst/>
-          </a:prstGeom>
-          <a:solidFill>
-            <a:srgbClr val="FAA1A1"/>
-          </a:solidFill>
-          <a:ln/>
-        </p:spPr>
-        <p:txBody>
-          <a:bodyPr/>
-          <a:lstStyle/>
-          <a:p>
-            <a:endParaRPr lang="en-US"/>
-          </a:p>
-        </p:txBody>
-      </p:sp>
-      <p:sp>
-        <p:nvSpPr>
-          <p:cNvPr id="42" name="Text 35"/>
-          <p:cNvSpPr/>
-          <p:nvPr/>
-        </p:nvSpPr>
-        <p:spPr>
-          <a:xfrm>
-            <a:off x="8316159" y="5849183"/>
-            <a:ext cx="1633180" cy="217289"/>
-          </a:xfrm>
-          <a:prstGeom prst="rect">
-            <a:avLst/>
-          </a:prstGeom>
-          <a:noFill/>
-          <a:ln/>
-        </p:spPr>
-        <p:txBody>
-          <a:bodyPr wrap="none" lIns="0" tIns="0" rIns="0" bIns="0" rtlCol="0" anchor="t"/>
-          <a:lstStyle/>
-          <a:p>
-            <a:pPr marL="0" indent="0" algn="l">
-              <a:lnSpc>
-                <a:spcPts val="1700"/>
-              </a:lnSpc>
-              <a:buNone/>
-            </a:pPr>
-            <a:r>
-              <a:rPr lang="en-US" sz="1300" dirty="0">
-                <a:solidFill>
-                  <a:srgbClr val="272525"/>
-                </a:solidFill>
-                <a:latin typeface="Heebo" pitchFamily="34" charset="0"/>
-                <a:ea typeface="Heebo" pitchFamily="34" charset="-122"/>
-                <a:cs typeface="Heebo" pitchFamily="34" charset="-120"/>
-              </a:rPr>
-              <a:t>38116</a:t>
-            </a:r>
-            <a:endParaRPr lang="en-US" sz="1300" dirty="0"/>
-          </a:p>
-        </p:txBody>
-      </p:sp>
-      <p:sp>
-        <p:nvSpPr>
-          <p:cNvPr id="43" name="Shape 36"/>
-          <p:cNvSpPr/>
-          <p:nvPr/>
-        </p:nvSpPr>
-        <p:spPr>
-          <a:xfrm>
-            <a:off x="10089000" y="5792747"/>
-            <a:ext cx="1908691" cy="330160"/>
-          </a:xfrm>
-          <a:prstGeom prst="rect">
-            <a:avLst/>
-          </a:prstGeom>
-          <a:solidFill>
-            <a:srgbClr val="FAA1A1"/>
-          </a:solidFill>
-          <a:ln/>
-        </p:spPr>
-        <p:txBody>
-          <a:bodyPr/>
-          <a:lstStyle/>
-          <a:p>
-            <a:endParaRPr lang="en-US"/>
-          </a:p>
-        </p:txBody>
-      </p:sp>
-      <p:sp>
-        <p:nvSpPr>
-          <p:cNvPr id="44" name="Text 37"/>
-          <p:cNvSpPr/>
-          <p:nvPr/>
-        </p:nvSpPr>
-        <p:spPr>
-          <a:xfrm>
-            <a:off x="10228660" y="5849183"/>
-            <a:ext cx="1629370" cy="217289"/>
-          </a:xfrm>
-          <a:prstGeom prst="rect">
-            <a:avLst/>
-          </a:prstGeom>
-          <a:noFill/>
-          <a:ln/>
-        </p:spPr>
-        <p:txBody>
-          <a:bodyPr wrap="none" lIns="0" tIns="0" rIns="0" bIns="0" rtlCol="0" anchor="t"/>
-          <a:lstStyle/>
-          <a:p>
-            <a:pPr marL="0" indent="0" algn="l">
-              <a:lnSpc>
-                <a:spcPts val="1700"/>
-              </a:lnSpc>
-              <a:buNone/>
-            </a:pPr>
-            <a:r>
-              <a:rPr lang="en-US" sz="1300" dirty="0">
-                <a:solidFill>
-                  <a:srgbClr val="272525"/>
-                </a:solidFill>
-                <a:latin typeface="Heebo" pitchFamily="34" charset="0"/>
-                <a:ea typeface="Heebo" pitchFamily="34" charset="-122"/>
-                <a:cs typeface="Heebo" pitchFamily="34" charset="-120"/>
-              </a:rPr>
-              <a:t>~40K</a:t>
-            </a:r>
-            <a:endParaRPr lang="en-US" sz="1300" dirty="0"/>
-          </a:p>
-        </p:txBody>
-      </p:sp>
-      <p:sp>
-        <p:nvSpPr>
-          <p:cNvPr id="45" name="Shape 38"/>
-          <p:cNvSpPr/>
-          <p:nvPr/>
-        </p:nvSpPr>
-        <p:spPr>
-          <a:xfrm>
-            <a:off x="11997691" y="5792747"/>
-            <a:ext cx="1908691" cy="330160"/>
-          </a:xfrm>
-          <a:prstGeom prst="rect">
-            <a:avLst/>
-          </a:prstGeom>
-          <a:solidFill>
-            <a:srgbClr val="FAA1A1"/>
-          </a:solidFill>
-          <a:ln/>
-        </p:spPr>
-        <p:txBody>
-          <a:bodyPr/>
-          <a:lstStyle/>
-          <a:p>
-            <a:endParaRPr lang="en-US"/>
-          </a:p>
-        </p:txBody>
-      </p:sp>
-      <p:sp>
-        <p:nvSpPr>
-          <p:cNvPr id="46" name="Text 39"/>
-          <p:cNvSpPr/>
-          <p:nvPr/>
-        </p:nvSpPr>
-        <p:spPr>
-          <a:xfrm>
-            <a:off x="12137351" y="5849183"/>
-            <a:ext cx="1633180" cy="217289"/>
-          </a:xfrm>
-          <a:prstGeom prst="rect">
-            <a:avLst/>
-          </a:prstGeom>
-          <a:noFill/>
-          <a:ln/>
-        </p:spPr>
-        <p:txBody>
-          <a:bodyPr wrap="none" lIns="0" tIns="0" rIns="0" bIns="0" rtlCol="0" anchor="t"/>
-          <a:lstStyle/>
-          <a:p>
-            <a:pPr marL="0" indent="0" algn="l">
-              <a:lnSpc>
-                <a:spcPts val="1700"/>
-              </a:lnSpc>
-              <a:buNone/>
-            </a:pPr>
-            <a:r>
-              <a:rPr lang="en-US" sz="1300" dirty="0">
-                <a:solidFill>
-                  <a:srgbClr val="272525"/>
-                </a:solidFill>
-                <a:latin typeface="Heebo" pitchFamily="34" charset="0"/>
-                <a:ea typeface="Heebo" pitchFamily="34" charset="-122"/>
-                <a:cs typeface="Heebo" pitchFamily="34" charset="-120"/>
-              </a:rPr>
-              <a:t>12 sq mi</a:t>
-            </a:r>
-            <a:endParaRPr lang="en-US" sz="1300" dirty="0"/>
-          </a:p>
-        </p:txBody>
-      </p:sp>
-      <p:sp>
-        <p:nvSpPr>
-          <p:cNvPr id="47" name="Shape 40"/>
-          <p:cNvSpPr/>
-          <p:nvPr/>
-        </p:nvSpPr>
-        <p:spPr>
-          <a:xfrm>
-            <a:off x="8179475" y="6122907"/>
-            <a:ext cx="5726906" cy="330160"/>
-          </a:xfrm>
-          <a:prstGeom prst="rect">
-            <a:avLst/>
-          </a:prstGeom>
-          <a:solidFill>
-            <a:srgbClr val="000000">
-              <a:alpha val="4000"/>
-            </a:srgbClr>
-          </a:solidFill>
-          <a:ln/>
-        </p:spPr>
-        <p:txBody>
-          <a:bodyPr/>
-          <a:lstStyle/>
-          <a:p>
-            <a:endParaRPr lang="en-US"/>
-          </a:p>
-        </p:txBody>
-      </p:sp>
-      <p:sp>
-        <p:nvSpPr>
-          <p:cNvPr id="48" name="Shape 41"/>
-          <p:cNvSpPr/>
-          <p:nvPr/>
-        </p:nvSpPr>
-        <p:spPr>
-          <a:xfrm>
-            <a:off x="8180309" y="6122907"/>
-            <a:ext cx="1908691" cy="330160"/>
-          </a:xfrm>
-          <a:prstGeom prst="rect">
-            <a:avLst/>
-          </a:prstGeom>
-          <a:solidFill>
-            <a:srgbClr val="AEE4BD"/>
-          </a:solidFill>
-          <a:ln/>
-        </p:spPr>
-        <p:txBody>
-          <a:bodyPr/>
-          <a:lstStyle/>
-          <a:p>
-            <a:endParaRPr lang="en-US"/>
-          </a:p>
-        </p:txBody>
-      </p:sp>
-      <p:sp>
-        <p:nvSpPr>
-          <p:cNvPr id="49" name="Text 42"/>
-          <p:cNvSpPr/>
-          <p:nvPr/>
-        </p:nvSpPr>
-        <p:spPr>
-          <a:xfrm>
-            <a:off x="8316159" y="6179343"/>
-            <a:ext cx="1633180" cy="217289"/>
-          </a:xfrm>
-          <a:prstGeom prst="rect">
-            <a:avLst/>
-          </a:prstGeom>
-          <a:noFill/>
-          <a:ln/>
-        </p:spPr>
-        <p:txBody>
-          <a:bodyPr wrap="none" lIns="0" tIns="0" rIns="0" bIns="0" rtlCol="0" anchor="t"/>
-          <a:lstStyle/>
-          <a:p>
-            <a:pPr marL="0" indent="0" algn="l">
-              <a:lnSpc>
-                <a:spcPts val="1700"/>
-              </a:lnSpc>
-              <a:buNone/>
-            </a:pPr>
-            <a:r>
-              <a:rPr lang="en-US" sz="1300" dirty="0">
-                <a:solidFill>
-                  <a:srgbClr val="272525"/>
-                </a:solidFill>
-                <a:latin typeface="Heebo" pitchFamily="34" charset="0"/>
-                <a:ea typeface="Heebo" pitchFamily="34" charset="-122"/>
-                <a:cs typeface="Heebo" pitchFamily="34" charset="-120"/>
-              </a:rPr>
-              <a:t>38117</a:t>
-            </a:r>
-            <a:endParaRPr lang="en-US" sz="1300" dirty="0"/>
-          </a:p>
-        </p:txBody>
-      </p:sp>
-      <p:sp>
-        <p:nvSpPr>
-          <p:cNvPr id="50" name="Shape 43"/>
-          <p:cNvSpPr/>
-          <p:nvPr/>
-        </p:nvSpPr>
-        <p:spPr>
-          <a:xfrm>
-            <a:off x="10089000" y="6122907"/>
-            <a:ext cx="1908691" cy="330160"/>
-          </a:xfrm>
-          <a:prstGeom prst="rect">
-            <a:avLst/>
-          </a:prstGeom>
-          <a:solidFill>
-            <a:srgbClr val="AEE4BD"/>
-          </a:solidFill>
-          <a:ln/>
-        </p:spPr>
-        <p:txBody>
-          <a:bodyPr/>
-          <a:lstStyle/>
-          <a:p>
-            <a:endParaRPr lang="en-US"/>
-          </a:p>
-        </p:txBody>
-      </p:sp>
-      <p:sp>
-        <p:nvSpPr>
-          <p:cNvPr id="51" name="Text 44"/>
-          <p:cNvSpPr/>
-          <p:nvPr/>
-        </p:nvSpPr>
-        <p:spPr>
-          <a:xfrm>
-            <a:off x="10228660" y="6179343"/>
-            <a:ext cx="1629370" cy="217289"/>
-          </a:xfrm>
-          <a:prstGeom prst="rect">
-            <a:avLst/>
-          </a:prstGeom>
-          <a:noFill/>
-          <a:ln/>
-        </p:spPr>
-        <p:txBody>
-          <a:bodyPr wrap="none" lIns="0" tIns="0" rIns="0" bIns="0" rtlCol="0" anchor="t"/>
-          <a:lstStyle/>
-          <a:p>
-            <a:pPr marL="0" indent="0" algn="l">
-              <a:lnSpc>
-                <a:spcPts val="1700"/>
-              </a:lnSpc>
-              <a:buNone/>
-            </a:pPr>
-            <a:r>
-              <a:rPr lang="en-US" sz="1300" dirty="0">
-                <a:solidFill>
-                  <a:srgbClr val="272525"/>
-                </a:solidFill>
-                <a:latin typeface="Heebo" pitchFamily="34" charset="0"/>
-                <a:ea typeface="Heebo" pitchFamily="34" charset="-122"/>
-                <a:cs typeface="Heebo" pitchFamily="34" charset="-120"/>
-              </a:rPr>
-              <a:t>~26K</a:t>
-            </a:r>
-            <a:endParaRPr lang="en-US" sz="1300" dirty="0"/>
-          </a:p>
-        </p:txBody>
-      </p:sp>
-      <p:sp>
-        <p:nvSpPr>
-          <p:cNvPr id="52" name="Shape 45"/>
-          <p:cNvSpPr/>
-          <p:nvPr/>
-        </p:nvSpPr>
-        <p:spPr>
-          <a:xfrm>
-            <a:off x="11997691" y="6122907"/>
-            <a:ext cx="1908691" cy="330160"/>
-          </a:xfrm>
-          <a:prstGeom prst="rect">
-            <a:avLst/>
-          </a:prstGeom>
-          <a:solidFill>
-            <a:srgbClr val="AEE4BD"/>
-          </a:solidFill>
-          <a:ln/>
-        </p:spPr>
-        <p:txBody>
-          <a:bodyPr/>
-          <a:lstStyle/>
-          <a:p>
-            <a:endParaRPr lang="en-US"/>
-          </a:p>
-        </p:txBody>
-      </p:sp>
-      <p:sp>
-        <p:nvSpPr>
-          <p:cNvPr id="53" name="Text 46"/>
-          <p:cNvSpPr/>
-          <p:nvPr/>
-        </p:nvSpPr>
-        <p:spPr>
-          <a:xfrm>
-            <a:off x="12137351" y="6179343"/>
-            <a:ext cx="1633180" cy="217289"/>
-          </a:xfrm>
-          <a:prstGeom prst="rect">
-            <a:avLst/>
-          </a:prstGeom>
-          <a:noFill/>
-          <a:ln/>
-        </p:spPr>
-        <p:txBody>
-          <a:bodyPr wrap="none" lIns="0" tIns="0" rIns="0" bIns="0" rtlCol="0" anchor="t"/>
-          <a:lstStyle/>
-          <a:p>
-            <a:pPr marL="0" indent="0" algn="l">
-              <a:lnSpc>
-                <a:spcPts val="1700"/>
-              </a:lnSpc>
-              <a:buNone/>
-            </a:pPr>
-            <a:r>
-              <a:rPr lang="en-US" sz="1300" dirty="0">
-                <a:solidFill>
-                  <a:srgbClr val="272525"/>
-                </a:solidFill>
-                <a:latin typeface="Heebo" pitchFamily="34" charset="0"/>
-                <a:ea typeface="Heebo" pitchFamily="34" charset="-122"/>
-                <a:cs typeface="Heebo" pitchFamily="34" charset="-120"/>
-              </a:rPr>
-              <a:t>9 sq mi</a:t>
-            </a:r>
-            <a:endParaRPr lang="en-US" sz="1300" dirty="0"/>
-          </a:p>
-        </p:txBody>
-      </p:sp>
-      <p:sp>
-        <p:nvSpPr>
-          <p:cNvPr id="54" name="Shape 47"/>
-          <p:cNvSpPr/>
-          <p:nvPr/>
-        </p:nvSpPr>
-        <p:spPr>
-          <a:xfrm>
-            <a:off x="731758" y="6953488"/>
-            <a:ext cx="13166884" cy="430411"/>
-          </a:xfrm>
-          <a:prstGeom prst="roundRect">
-            <a:avLst>
-              <a:gd name="adj" fmla="val 4737"/>
-            </a:avLst>
-          </a:prstGeom>
-          <a:solidFill>
-            <a:srgbClr val="B3C3FF"/>
-          </a:solidFill>
-          <a:ln/>
-        </p:spPr>
-        <p:txBody>
-          <a:bodyPr/>
-          <a:lstStyle/>
-          <a:p>
-            <a:endParaRPr lang="en-US"/>
-          </a:p>
-        </p:txBody>
-      </p:sp>
-      <p:pic>
-        <p:nvPicPr>
-          <p:cNvPr id="55" name="Image 5" descr="preencoded.png"/>
-          <p:cNvPicPr>
-            <a:picLocks noChangeAspect="1"/>
-          </p:cNvPicPr>
-          <p:nvPr/>
-        </p:nvPicPr>
-        <p:blipFill>
-          <a:blip r:embed="rId8"/>
-          <a:stretch>
-            <a:fillRect/>
-          </a:stretch>
-        </p:blipFill>
-        <p:spPr>
-          <a:xfrm>
-            <a:off x="867608" y="7126248"/>
-            <a:ext cx="169783" cy="135850"/>
-          </a:xfrm>
-          <a:prstGeom prst="rect">
-            <a:avLst/>
-          </a:prstGeom>
-        </p:spPr>
-      </p:pic>
-      <p:sp>
-        <p:nvSpPr>
-          <p:cNvPr id="56" name="Text 48"/>
-          <p:cNvSpPr/>
-          <p:nvPr/>
-        </p:nvSpPr>
-        <p:spPr>
-          <a:xfrm>
-            <a:off x="1173242" y="7068860"/>
-            <a:ext cx="12589550" cy="173950"/>
-          </a:xfrm>
-          <a:prstGeom prst="rect">
-            <a:avLst/>
-          </a:prstGeom>
-          <a:noFill/>
-          <a:ln/>
-        </p:spPr>
-        <p:txBody>
-          <a:bodyPr wrap="none" lIns="0" tIns="0" rIns="0" bIns="0" rtlCol="0" anchor="t"/>
-          <a:lstStyle/>
-          <a:p>
-            <a:pPr marL="0" indent="0" algn="l">
-              <a:lnSpc>
-                <a:spcPts val="1350"/>
-              </a:lnSpc>
-              <a:buNone/>
-            </a:pPr>
-            <a:r>
-              <a:rPr lang="en-US" sz="1050" b="1" dirty="0">
-                <a:solidFill>
-                  <a:srgbClr val="000000"/>
-                </a:solidFill>
-                <a:latin typeface="Heebo" pitchFamily="34" charset="0"/>
-                <a:ea typeface="Heebo" pitchFamily="34" charset="-122"/>
-                <a:cs typeface="Heebo" pitchFamily="34" charset="-120"/>
-              </a:rPr>
-              <a:t>Economy, mobility, food, and healthcare access intersect here.</a:t>
-            </a:r>
-            <a:r>
-              <a:rPr lang="en-US" sz="1050" dirty="0">
-                <a:solidFill>
-                  <a:srgbClr val="000000"/>
-                </a:solidFill>
-                <a:latin typeface="Heebo" pitchFamily="34" charset="0"/>
-                <a:ea typeface="Heebo" pitchFamily="34" charset="-122"/>
-                <a:cs typeface="Heebo" pitchFamily="34" charset="-120"/>
-              </a:rPr>
-              <a:t> This is a concentrated, addressable geography with overlapping vulnerabilities.</a:t>
-            </a:r>
-            <a:endParaRPr lang="en-US" sz="1050" dirty="0"/>
-          </a:p>
-        </p:txBody>
-      </p:sp>
-      <p:sp>
-        <p:nvSpPr>
-          <p:cNvPr id="57" name="Text 49"/>
-          <p:cNvSpPr/>
-          <p:nvPr/>
-        </p:nvSpPr>
-        <p:spPr>
-          <a:xfrm>
-            <a:off x="731758" y="7475458"/>
-            <a:ext cx="13166884" cy="139065"/>
-          </a:xfrm>
-          <a:prstGeom prst="rect">
-            <a:avLst/>
-          </a:prstGeom>
-          <a:noFill/>
-          <a:ln/>
-        </p:spPr>
-        <p:txBody>
-          <a:bodyPr wrap="none" lIns="0" tIns="0" rIns="0" bIns="0" rtlCol="0" anchor="t"/>
-          <a:lstStyle/>
-          <a:p>
-            <a:pPr marL="0" indent="0" algn="l">
-              <a:lnSpc>
-                <a:spcPts val="1050"/>
-              </a:lnSpc>
-              <a:buNone/>
-            </a:pPr>
-            <a:r>
-              <a:rPr lang="en-US" sz="850" i="1" dirty="0">
-                <a:solidFill>
-                  <a:srgbClr val="4C4C4D"/>
-                </a:solidFill>
-                <a:latin typeface="Heebo" pitchFamily="34" charset="0"/>
-                <a:ea typeface="Heebo" pitchFamily="34" charset="-122"/>
-                <a:cs typeface="Heebo" pitchFamily="34" charset="-120"/>
-              </a:rPr>
-              <a:t>Source: IGS, ACS/Census, healthcare enrichment, uploaded analysis charts.</a:t>
-            </a:r>
-            <a:endParaRPr lang="en-US" sz="850" dirty="0"/>
-          </a:p>
-        </p:txBody>
-      </p:sp>
     </p:spTree>
   </p:cSld>
   <p:clrMapOvr>
@@ -11590,7 +11686,7 @@
           <a:bodyPr wrap="none" lIns="0" tIns="0" rIns="0" bIns="0" rtlCol="0" anchor="t"/>
           <a:lstStyle/>
           <a:p>
-            <a:pPr marL="0" indent="0" algn="l">
+            <a:pPr marL="0" indent="0" algn="ctr">
               <a:lnSpc>
                 <a:spcPts val="2900"/>
               </a:lnSpc>
@@ -11870,7 +11966,7 @@
           <a:bodyPr/>
           <a:lstStyle/>
           <a:p>
-            <a:endParaRPr lang="en-US"/>
+            <a:endParaRPr lang="en-US" dirty="0"/>
           </a:p>
         </p:txBody>
       </p:sp>
@@ -12377,6 +12473,397 @@
   <p:clrMapOvr>
     <a:masterClrMapping/>
   </p:clrMapOvr>
+  <p:timing>
+    <p:tnLst>
+      <p:par>
+        <p:cTn id="1" dur="indefinite" restart="never" nodeType="tmRoot">
+          <p:childTnLst>
+            <p:seq concurrent="1" nextAc="seek">
+              <p:cTn id="2" dur="indefinite" nodeType="mainSeq">
+                <p:childTnLst>
+                  <p:par>
+                    <p:cTn id="3" fill="hold">
+                      <p:stCondLst>
+                        <p:cond delay="indefinite"/>
+                      </p:stCondLst>
+                      <p:childTnLst>
+                        <p:par>
+                          <p:cTn id="4" fill="hold">
+                            <p:stCondLst>
+                              <p:cond delay="0"/>
+                            </p:stCondLst>
+                            <p:childTnLst>
+                              <p:par>
+                                <p:cTn id="5" presetID="10" presetClass="entr" presetSubtype="0" fill="hold" grpId="0" nodeType="clickEffect">
+                                  <p:stCondLst>
+                                    <p:cond delay="0"/>
+                                  </p:stCondLst>
+                                  <p:childTnLst>
+                                    <p:set>
+                                      <p:cBhvr>
+                                        <p:cTn id="6" dur="1" fill="hold">
+                                          <p:stCondLst>
+                                            <p:cond delay="0"/>
+                                          </p:stCondLst>
+                                        </p:cTn>
+                                        <p:tgtEl>
+                                          <p:spTgt spid="9"/>
+                                        </p:tgtEl>
+                                        <p:attrNameLst>
+                                          <p:attrName>style.visibility</p:attrName>
+                                        </p:attrNameLst>
+                                      </p:cBhvr>
+                                      <p:to>
+                                        <p:strVal val="visible"/>
+                                      </p:to>
+                                    </p:set>
+                                    <p:animEffect transition="in" filter="fade">
+                                      <p:cBhvr>
+                                        <p:cTn id="7" dur="500"/>
+                                        <p:tgtEl>
+                                          <p:spTgt spid="9"/>
+                                        </p:tgtEl>
+                                      </p:cBhvr>
+                                    </p:animEffect>
+                                  </p:childTnLst>
+                                </p:cTn>
+                              </p:par>
+                              <p:par>
+                                <p:cTn id="8" presetID="10" presetClass="entr" presetSubtype="0" fill="hold" grpId="0" nodeType="withEffect">
+                                  <p:stCondLst>
+                                    <p:cond delay="0"/>
+                                  </p:stCondLst>
+                                  <p:childTnLst>
+                                    <p:set>
+                                      <p:cBhvr>
+                                        <p:cTn id="9" dur="1" fill="hold">
+                                          <p:stCondLst>
+                                            <p:cond delay="0"/>
+                                          </p:stCondLst>
+                                        </p:cTn>
+                                        <p:tgtEl>
+                                          <p:spTgt spid="10"/>
+                                        </p:tgtEl>
+                                        <p:attrNameLst>
+                                          <p:attrName>style.visibility</p:attrName>
+                                        </p:attrNameLst>
+                                      </p:cBhvr>
+                                      <p:to>
+                                        <p:strVal val="visible"/>
+                                      </p:to>
+                                    </p:set>
+                                    <p:animEffect transition="in" filter="fade">
+                                      <p:cBhvr>
+                                        <p:cTn id="10" dur="500"/>
+                                        <p:tgtEl>
+                                          <p:spTgt spid="10"/>
+                                        </p:tgtEl>
+                                      </p:cBhvr>
+                                    </p:animEffect>
+                                  </p:childTnLst>
+                                </p:cTn>
+                              </p:par>
+                              <p:par>
+                                <p:cTn id="11" presetID="10" presetClass="entr" presetSubtype="0" fill="hold" nodeType="withEffect">
+                                  <p:stCondLst>
+                                    <p:cond delay="0"/>
+                                  </p:stCondLst>
+                                  <p:childTnLst>
+                                    <p:set>
+                                      <p:cBhvr>
+                                        <p:cTn id="12" dur="1" fill="hold">
+                                          <p:stCondLst>
+                                            <p:cond delay="0"/>
+                                          </p:stCondLst>
+                                        </p:cTn>
+                                        <p:tgtEl>
+                                          <p:spTgt spid="11"/>
+                                        </p:tgtEl>
+                                        <p:attrNameLst>
+                                          <p:attrName>style.visibility</p:attrName>
+                                        </p:attrNameLst>
+                                      </p:cBhvr>
+                                      <p:to>
+                                        <p:strVal val="visible"/>
+                                      </p:to>
+                                    </p:set>
+                                    <p:animEffect transition="in" filter="fade">
+                                      <p:cBhvr>
+                                        <p:cTn id="13" dur="500"/>
+                                        <p:tgtEl>
+                                          <p:spTgt spid="11"/>
+                                        </p:tgtEl>
+                                      </p:cBhvr>
+                                    </p:animEffect>
+                                  </p:childTnLst>
+                                </p:cTn>
+                              </p:par>
+                              <p:par>
+                                <p:cTn id="14" presetID="10" presetClass="entr" presetSubtype="0" fill="hold" grpId="0" nodeType="withEffect">
+                                  <p:stCondLst>
+                                    <p:cond delay="0"/>
+                                  </p:stCondLst>
+                                  <p:childTnLst>
+                                    <p:set>
+                                      <p:cBhvr>
+                                        <p:cTn id="15" dur="1" fill="hold">
+                                          <p:stCondLst>
+                                            <p:cond delay="0"/>
+                                          </p:stCondLst>
+                                        </p:cTn>
+                                        <p:tgtEl>
+                                          <p:spTgt spid="12"/>
+                                        </p:tgtEl>
+                                        <p:attrNameLst>
+                                          <p:attrName>style.visibility</p:attrName>
+                                        </p:attrNameLst>
+                                      </p:cBhvr>
+                                      <p:to>
+                                        <p:strVal val="visible"/>
+                                      </p:to>
+                                    </p:set>
+                                    <p:animEffect transition="in" filter="fade">
+                                      <p:cBhvr>
+                                        <p:cTn id="16" dur="500"/>
+                                        <p:tgtEl>
+                                          <p:spTgt spid="12"/>
+                                        </p:tgtEl>
+                                      </p:cBhvr>
+                                    </p:animEffect>
+                                  </p:childTnLst>
+                                </p:cTn>
+                              </p:par>
+                              <p:par>
+                                <p:cTn id="17" presetID="10" presetClass="entr" presetSubtype="0" fill="hold" grpId="0" nodeType="withEffect">
+                                  <p:stCondLst>
+                                    <p:cond delay="0"/>
+                                  </p:stCondLst>
+                                  <p:childTnLst>
+                                    <p:set>
+                                      <p:cBhvr>
+                                        <p:cTn id="18" dur="1" fill="hold">
+                                          <p:stCondLst>
+                                            <p:cond delay="0"/>
+                                          </p:stCondLst>
+                                        </p:cTn>
+                                        <p:tgtEl>
+                                          <p:spTgt spid="13"/>
+                                        </p:tgtEl>
+                                        <p:attrNameLst>
+                                          <p:attrName>style.visibility</p:attrName>
+                                        </p:attrNameLst>
+                                      </p:cBhvr>
+                                      <p:to>
+                                        <p:strVal val="visible"/>
+                                      </p:to>
+                                    </p:set>
+                                    <p:animEffect transition="in" filter="fade">
+                                      <p:cBhvr>
+                                        <p:cTn id="19" dur="500"/>
+                                        <p:tgtEl>
+                                          <p:spTgt spid="13"/>
+                                        </p:tgtEl>
+                                      </p:cBhvr>
+                                    </p:animEffect>
+                                  </p:childTnLst>
+                                </p:cTn>
+                              </p:par>
+                            </p:childTnLst>
+                          </p:cTn>
+                        </p:par>
+                      </p:childTnLst>
+                    </p:cTn>
+                  </p:par>
+                  <p:par>
+                    <p:cTn id="20" fill="hold">
+                      <p:stCondLst>
+                        <p:cond delay="indefinite"/>
+                      </p:stCondLst>
+                      <p:childTnLst>
+                        <p:par>
+                          <p:cTn id="21" fill="hold">
+                            <p:stCondLst>
+                              <p:cond delay="0"/>
+                            </p:stCondLst>
+                            <p:childTnLst>
+                              <p:par>
+                                <p:cTn id="22" presetID="10" presetClass="entr" presetSubtype="0" fill="hold" grpId="0" nodeType="clickEffect">
+                                  <p:stCondLst>
+                                    <p:cond delay="0"/>
+                                  </p:stCondLst>
+                                  <p:childTnLst>
+                                    <p:set>
+                                      <p:cBhvr>
+                                        <p:cTn id="23" dur="1" fill="hold">
+                                          <p:stCondLst>
+                                            <p:cond delay="0"/>
+                                          </p:stCondLst>
+                                        </p:cTn>
+                                        <p:tgtEl>
+                                          <p:spTgt spid="14"/>
+                                        </p:tgtEl>
+                                        <p:attrNameLst>
+                                          <p:attrName>style.visibility</p:attrName>
+                                        </p:attrNameLst>
+                                      </p:cBhvr>
+                                      <p:to>
+                                        <p:strVal val="visible"/>
+                                      </p:to>
+                                    </p:set>
+                                    <p:animEffect transition="in" filter="fade">
+                                      <p:cBhvr>
+                                        <p:cTn id="24" dur="500"/>
+                                        <p:tgtEl>
+                                          <p:spTgt spid="14"/>
+                                        </p:tgtEl>
+                                      </p:cBhvr>
+                                    </p:animEffect>
+                                  </p:childTnLst>
+                                </p:cTn>
+                              </p:par>
+                              <p:par>
+                                <p:cTn id="25" presetID="10" presetClass="entr" presetSubtype="0" fill="hold" grpId="0" nodeType="withEffect">
+                                  <p:stCondLst>
+                                    <p:cond delay="0"/>
+                                  </p:stCondLst>
+                                  <p:childTnLst>
+                                    <p:set>
+                                      <p:cBhvr>
+                                        <p:cTn id="26" dur="1" fill="hold">
+                                          <p:stCondLst>
+                                            <p:cond delay="0"/>
+                                          </p:stCondLst>
+                                        </p:cTn>
+                                        <p:tgtEl>
+                                          <p:spTgt spid="15"/>
+                                        </p:tgtEl>
+                                        <p:attrNameLst>
+                                          <p:attrName>style.visibility</p:attrName>
+                                        </p:attrNameLst>
+                                      </p:cBhvr>
+                                      <p:to>
+                                        <p:strVal val="visible"/>
+                                      </p:to>
+                                    </p:set>
+                                    <p:animEffect transition="in" filter="fade">
+                                      <p:cBhvr>
+                                        <p:cTn id="27" dur="500"/>
+                                        <p:tgtEl>
+                                          <p:spTgt spid="15"/>
+                                        </p:tgtEl>
+                                      </p:cBhvr>
+                                    </p:animEffect>
+                                  </p:childTnLst>
+                                </p:cTn>
+                              </p:par>
+                              <p:par>
+                                <p:cTn id="28" presetID="10" presetClass="entr" presetSubtype="0" fill="hold" grpId="0" nodeType="withEffect">
+                                  <p:stCondLst>
+                                    <p:cond delay="0"/>
+                                  </p:stCondLst>
+                                  <p:childTnLst>
+                                    <p:set>
+                                      <p:cBhvr>
+                                        <p:cTn id="29" dur="1" fill="hold">
+                                          <p:stCondLst>
+                                            <p:cond delay="0"/>
+                                          </p:stCondLst>
+                                        </p:cTn>
+                                        <p:tgtEl>
+                                          <p:spTgt spid="17"/>
+                                        </p:tgtEl>
+                                        <p:attrNameLst>
+                                          <p:attrName>style.visibility</p:attrName>
+                                        </p:attrNameLst>
+                                      </p:cBhvr>
+                                      <p:to>
+                                        <p:strVal val="visible"/>
+                                      </p:to>
+                                    </p:set>
+                                    <p:animEffect transition="in" filter="fade">
+                                      <p:cBhvr>
+                                        <p:cTn id="30" dur="500"/>
+                                        <p:tgtEl>
+                                          <p:spTgt spid="17"/>
+                                        </p:tgtEl>
+                                      </p:cBhvr>
+                                    </p:animEffect>
+                                  </p:childTnLst>
+                                </p:cTn>
+                              </p:par>
+                              <p:par>
+                                <p:cTn id="31" presetID="10" presetClass="entr" presetSubtype="0" fill="hold" grpId="0" nodeType="withEffect">
+                                  <p:stCondLst>
+                                    <p:cond delay="0"/>
+                                  </p:stCondLst>
+                                  <p:childTnLst>
+                                    <p:set>
+                                      <p:cBhvr>
+                                        <p:cTn id="32" dur="1" fill="hold">
+                                          <p:stCondLst>
+                                            <p:cond delay="0"/>
+                                          </p:stCondLst>
+                                        </p:cTn>
+                                        <p:tgtEl>
+                                          <p:spTgt spid="18"/>
+                                        </p:tgtEl>
+                                        <p:attrNameLst>
+                                          <p:attrName>style.visibility</p:attrName>
+                                        </p:attrNameLst>
+                                      </p:cBhvr>
+                                      <p:to>
+                                        <p:strVal val="visible"/>
+                                      </p:to>
+                                    </p:set>
+                                    <p:animEffect transition="in" filter="fade">
+                                      <p:cBhvr>
+                                        <p:cTn id="33" dur="500"/>
+                                        <p:tgtEl>
+                                          <p:spTgt spid="18"/>
+                                        </p:tgtEl>
+                                      </p:cBhvr>
+                                    </p:animEffect>
+                                  </p:childTnLst>
+                                </p:cTn>
+                              </p:par>
+                            </p:childTnLst>
+                          </p:cTn>
+                        </p:par>
+                      </p:childTnLst>
+                    </p:cTn>
+                  </p:par>
+                </p:childTnLst>
+              </p:cTn>
+              <p:prevCondLst>
+                <p:cond evt="onPrev" delay="0">
+                  <p:tgtEl>
+                    <p:sldTgt/>
+                  </p:tgtEl>
+                </p:cond>
+              </p:prevCondLst>
+              <p:nextCondLst>
+                <p:cond evt="onNext" delay="0">
+                  <p:tgtEl>
+                    <p:sldTgt/>
+                  </p:tgtEl>
+                </p:cond>
+              </p:nextCondLst>
+            </p:seq>
+          </p:childTnLst>
+        </p:cTn>
+      </p:par>
+    </p:tnLst>
+    <p:bldLst>
+      <p:bldP spid="9" grpId="0" animBg="1"/>
+      <p:bldP spid="10" grpId="0" animBg="1"/>
+      <p:bldP spid="12" grpId="0" animBg="1"/>
+      <p:bldP spid="13" grpId="0" animBg="1"/>
+      <p:bldP spid="14" grpId="0" animBg="1"/>
+      <p:bldP spid="15" grpId="0" animBg="1"/>
+      <p:bldP spid="17" grpId="0" animBg="1"/>
+      <p:bldP spid="18" grpId="0" animBg="1"/>
+    </p:bldLst>
+  </p:timing>
 </p:sld>
 </file>
 
@@ -13154,7 +13641,7 @@
                 <a:ea typeface="Heebo" pitchFamily="34" charset="-122"/>
                 <a:cs typeface="Heebo" pitchFamily="34" charset="-120"/>
               </a:rPr>
-              <a:t>Source: IGS, ACS/Census, healthcare enrichment, uploaded analysis charts.</a:t>
+              <a:t>Source: IGS, ACS/Census, healthcare enrichment (ACS).</a:t>
             </a:r>
             <a:endParaRPr lang="en-US" sz="1050" dirty="0"/>
           </a:p>
@@ -13235,7 +13722,7 @@
         </p:nvSpPr>
         <p:spPr>
           <a:xfrm>
-            <a:off x="793790" y="1198364"/>
+            <a:off x="3527762" y="1186186"/>
             <a:ext cx="7701082" cy="368618"/>
           </a:xfrm>
           <a:prstGeom prst="rect">
@@ -14422,48 +14909,6 @@
               <a:t>Scale What Works</a:t>
             </a:r>
             <a:endParaRPr lang="en-US" sz="1500" dirty="0"/>
-          </a:p>
-        </p:txBody>
-      </p:sp>
-      <p:sp>
-        <p:nvSpPr>
-          <p:cNvPr id="29" name="Text 22"/>
-          <p:cNvSpPr/>
-          <p:nvPr/>
-        </p:nvSpPr>
-        <p:spPr>
-          <a:xfrm>
-            <a:off x="793790" y="7374493"/>
-            <a:ext cx="13042821" cy="155734"/>
-          </a:xfrm>
-          <a:prstGeom prst="rect">
-            <a:avLst/>
-          </a:prstGeom>
-          <a:noFill/>
-          <a:ln/>
-        </p:spPr>
-        <p:txBody>
-          <a:bodyPr wrap="none" lIns="0" tIns="0" rIns="0" bIns="0" rtlCol="0" anchor="t"/>
-          <a:lstStyle/>
-          <a:p>
-            <a:pPr marL="0" indent="0" algn="l">
-              <a:lnSpc>
-                <a:spcPts val="1200"/>
-              </a:lnSpc>
-              <a:buNone/>
-            </a:pPr>
-            <a:r>
-              <a:rPr lang="en-US" sz="900" i="1" dirty="0">
-                <a:solidFill>
-                  <a:srgbClr val="4C4C4D"/>
-                </a:solidFill>
-                <a:latin typeface="Heebo" pitchFamily="34" charset="0"/>
-                <a:ea typeface="Heebo" pitchFamily="34" charset="-122"/>
-                <a:cs typeface="Heebo" pitchFamily="34" charset="-120"/>
-              </a:rPr>
-              <a:t>Source: IGS, ACS/Census, healthcare enrichment, uploaded analysis charts.</a:t>
-            </a:r>
-            <a:endParaRPr lang="en-US" sz="900" dirty="0"/>
           </a:p>
         </p:txBody>
       </p:sp>

</xml_diff>